<commit_message>
Standardize teaching downloads and add editable companions
</commit_message>
<xml_diff>
--- a/assets/lessons/lectures/digital-signal-processing/fourier-project-2018.pptx
+++ b/assets/lessons/lectures/digital-signal-processing/fourier-project-2018.pptx
@@ -20,7 +20,7 @@
     <p:sldId id="266" r:id="rId11"/>
     <p:sldId id="267" r:id="rId12"/>
   </p:sldIdLst>
-  <p:sldSz cx="12192000" cy="6858000"/>
+  <p:sldSz cx="12192000" cy="7543800"/>
   <p:notesSz cx="6858000" cy="9144000"/>
   <p:defaultTextStyle>
     <a:defPPr>
@@ -122,6 +122,185 @@
 
 <file path=ppt/revisionInfo.xml><?xml version="1.0" encoding="utf-8"?>
 <p1510:revInfo xmlns:a="http://schemas.openxmlformats.org/drawingml/2006/main" xmlns:r="http://schemas.openxmlformats.org/officeDocument/2006/relationships" xmlns:p1510="http://schemas.microsoft.com/office/powerpoint/2015/10/main"/>
+</file>
+
+<file path=ppt/customXml/item1.xml><?xml version="1.0" encoding="utf-8"?>
+<ct:contentTypeSchema xmlns:ct="http://schemas.microsoft.com/office/2006/metadata/contentType" xmlns:ma="http://schemas.microsoft.com/office/2006/metadata/properties/metaAttributes" ct:_="" ma:_="" ma:contentTypeName="Document" ma:contentTypeID="0x01010016C36F108F9F92488C988DDF36346911" ma:contentTypeVersion="5" ma:contentTypeDescription="Create a new document." ma:contentTypeScope="" ma:versionID="c417924321fef32731141cd966ef6f94">
+  <xsd:schema xmlns:xsd="http://www.w3.org/2001/XMLSchema" xmlns:xs="http://www.w3.org/2001/XMLSchema" xmlns:p="http://schemas.microsoft.com/office/2006/metadata/properties" xmlns:ns2="1bb24863-89de-455f-aabf-4424925aa312" targetNamespace="http://schemas.microsoft.com/office/2006/metadata/properties" ma:root="true" ma:fieldsID="a7d3b2212d350eb904df17fc79fef4f4" ns2:_="">
+    <xsd:import namespace="1bb24863-89de-455f-aabf-4424925aa312"/>
+    <xsd:element name="properties">
+      <xsd:complexType>
+        <xsd:sequence>
+          <xsd:element name="documentManagement">
+            <xsd:complexType>
+              <xsd:all>
+                <xsd:element ref="ns2:MediaServiceMetadata" minOccurs="0"/>
+                <xsd:element ref="ns2:MediaServiceFastMetadata" minOccurs="0"/>
+                <xsd:element ref="ns2:MediaServiceAutoTags" minOccurs="0"/>
+                <xsd:element ref="ns2:MediaServiceOCR" minOccurs="0"/>
+                <xsd:element ref="ns2:MediaServiceDateTaken" minOccurs="0"/>
+              </xsd:all>
+            </xsd:complexType>
+          </xsd:element>
+        </xsd:sequence>
+      </xsd:complexType>
+    </xsd:element>
+  </xsd:schema>
+  <xsd:schema xmlns:xsd="http://www.w3.org/2001/XMLSchema" xmlns:xs="http://www.w3.org/2001/XMLSchema" xmlns:dms="http://schemas.microsoft.com/office/2006/documentManagement/types" xmlns:pc="http://schemas.microsoft.com/office/infopath/2007/PartnerControls" targetNamespace="1bb24863-89de-455f-aabf-4424925aa312" elementFormDefault="qualified">
+    <xsd:import namespace="http://schemas.microsoft.com/office/2006/documentManagement/types"/>
+    <xsd:import namespace="http://schemas.microsoft.com/office/infopath/2007/PartnerControls"/>
+    <xsd:element name="MediaServiceMetadata" ma:index="8" nillable="true" ma:displayName="MediaServiceMetadata" ma:hidden="true" ma:internalName="MediaServiceMetadata" ma:readOnly="true">
+      <xsd:simpleType>
+        <xsd:restriction base="dms:Note"/>
+      </xsd:simpleType>
+    </xsd:element>
+    <xsd:element name="MediaServiceFastMetadata" ma:index="9" nillable="true" ma:displayName="MediaServiceFastMetadata" ma:hidden="true" ma:internalName="MediaServiceFastMetadata" ma:readOnly="true">
+      <xsd:simpleType>
+        <xsd:restriction base="dms:Note"/>
+      </xsd:simpleType>
+    </xsd:element>
+    <xsd:element name="MediaServiceAutoTags" ma:index="10" nillable="true" ma:displayName="MediaServiceAutoTags" ma:internalName="MediaServiceAutoTags" ma:readOnly="true">
+      <xsd:simpleType>
+        <xsd:restriction base="dms:Text"/>
+      </xsd:simpleType>
+    </xsd:element>
+    <xsd:element name="MediaServiceOCR" ma:index="11" nillable="true" ma:displayName="MediaServiceOCR" ma:internalName="MediaServiceOCR" ma:readOnly="true">
+      <xsd:simpleType>
+        <xsd:restriction base="dms:Note">
+          <xsd:maxLength value="255"/>
+        </xsd:restriction>
+      </xsd:simpleType>
+    </xsd:element>
+    <xsd:element name="MediaServiceDateTaken" ma:index="12" nillable="true" ma:displayName="MediaServiceDateTaken" ma:hidden="true" ma:internalName="MediaServiceDateTaken" ma:readOnly="true">
+      <xsd:simpleType>
+        <xsd:restriction base="dms:Text"/>
+      </xsd:simpleType>
+    </xsd:element>
+  </xsd:schema>
+  <xsd:schema xmlns="http://schemas.openxmlformats.org/package/2006/metadata/core-properties" xmlns:xsd="http://www.w3.org/2001/XMLSchema" xmlns:xsi="http://www.w3.org/2001/XMLSchema-instance" xmlns:dc="http://purl.org/dc/elements/1.1/" xmlns:dcterms="http://purl.org/dc/terms/" xmlns:odoc="http://schemas.microsoft.com/internal/obd" targetNamespace="http://schemas.openxmlformats.org/package/2006/metadata/core-properties" elementFormDefault="qualified" attributeFormDefault="unqualified" blockDefault="#all">
+    <xsd:import namespace="http://purl.org/dc/elements/1.1/" schemaLocation="http://dublincore.org/schemas/xmls/qdc/2003/04/02/dc.xsd"/>
+    <xsd:import namespace="http://purl.org/dc/terms/" schemaLocation="http://dublincore.org/schemas/xmls/qdc/2003/04/02/dcterms.xsd"/>
+    <xsd:element name="coreProperties" type="CT_coreProperties"/>
+    <xsd:complexType name="CT_coreProperties">
+      <xsd:all>
+        <xsd:element ref="dc:creator" minOccurs="0" maxOccurs="1"/>
+        <xsd:element ref="dcterms:created" minOccurs="0" maxOccurs="1"/>
+        <xsd:element ref="dc:identifier" minOccurs="0" maxOccurs="1"/>
+        <xsd:element name="contentType" minOccurs="0" maxOccurs="1" type="xsd:string" ma:index="0" ma:displayName="Content Type"/>
+        <xsd:element ref="dc:title" minOccurs="0" maxOccurs="1" ma:index="4" ma:displayName="Title"/>
+        <xsd:element ref="dc:subject" minOccurs="0" maxOccurs="1"/>
+        <xsd:element ref="dc:description" minOccurs="0" maxOccurs="1"/>
+        <xsd:element name="keywords" minOccurs="0" maxOccurs="1" type="xsd:string"/>
+        <xsd:element ref="dc:language" minOccurs="0" maxOccurs="1"/>
+        <xsd:element name="category" minOccurs="0" maxOccurs="1" type="xsd:string"/>
+        <xsd:element name="version" minOccurs="0" maxOccurs="1" type="xsd:string"/>
+        <xsd:element name="revision" minOccurs="0" maxOccurs="1" type="xsd:string">
+          <xsd:annotation>
+            <xsd:documentation>
+                        This value indicates the number of saves or revisions. The application is responsible for updating this value after each revision.
+                    </xsd:documentation>
+          </xsd:annotation>
+        </xsd:element>
+        <xsd:element name="lastModifiedBy" minOccurs="0" maxOccurs="1" type="xsd:string"/>
+        <xsd:element ref="dcterms:modified" minOccurs="0" maxOccurs="1"/>
+        <xsd:element name="contentStatus" minOccurs="0" maxOccurs="1" type="xsd:string"/>
+      </xsd:all>
+    </xsd:complexType>
+  </xsd:schema>
+  <xs:schema xmlns:pc="http://schemas.microsoft.com/office/infopath/2007/PartnerControls" xmlns:xs="http://www.w3.org/2001/XMLSchema" targetNamespace="http://schemas.microsoft.com/office/infopath/2007/PartnerControls" elementFormDefault="qualified" attributeFormDefault="unqualified">
+    <xs:element name="Person">
+      <xs:complexType>
+        <xs:sequence>
+          <xs:element ref="pc:DisplayName" minOccurs="0"/>
+          <xs:element ref="pc:AccountId" minOccurs="0"/>
+          <xs:element ref="pc:AccountType" minOccurs="0"/>
+        </xs:sequence>
+      </xs:complexType>
+    </xs:element>
+    <xs:element name="DisplayName" type="xs:string"/>
+    <xs:element name="AccountId" type="xs:string"/>
+    <xs:element name="AccountType" type="xs:string"/>
+    <xs:element name="BDCAssociatedEntity">
+      <xs:complexType>
+        <xs:sequence>
+          <xs:element ref="pc:BDCEntity" minOccurs="0" maxOccurs="unbounded"/>
+        </xs:sequence>
+        <xs:attribute ref="pc:EntityNamespace"/>
+        <xs:attribute ref="pc:EntityName"/>
+        <xs:attribute ref="pc:SystemInstanceName"/>
+        <xs:attribute ref="pc:AssociationName"/>
+      </xs:complexType>
+    </xs:element>
+    <xs:attribute name="EntityNamespace" type="xs:string"/>
+    <xs:attribute name="EntityName" type="xs:string"/>
+    <xs:attribute name="SystemInstanceName" type="xs:string"/>
+    <xs:attribute name="AssociationName" type="xs:string"/>
+    <xs:element name="BDCEntity">
+      <xs:complexType>
+        <xs:sequence>
+          <xs:element ref="pc:EntityDisplayName" minOccurs="0"/>
+          <xs:element ref="pc:EntityInstanceReference" minOccurs="0"/>
+          <xs:element ref="pc:EntityId1" minOccurs="0"/>
+          <xs:element ref="pc:EntityId2" minOccurs="0"/>
+          <xs:element ref="pc:EntityId3" minOccurs="0"/>
+          <xs:element ref="pc:EntityId4" minOccurs="0"/>
+          <xs:element ref="pc:EntityId5" minOccurs="0"/>
+        </xs:sequence>
+      </xs:complexType>
+    </xs:element>
+    <xs:element name="EntityDisplayName" type="xs:string"/>
+    <xs:element name="EntityInstanceReference" type="xs:string"/>
+    <xs:element name="EntityId1" type="xs:string"/>
+    <xs:element name="EntityId2" type="xs:string"/>
+    <xs:element name="EntityId3" type="xs:string"/>
+    <xs:element name="EntityId4" type="xs:string"/>
+    <xs:element name="EntityId5" type="xs:string"/>
+    <xs:element name="Terms">
+      <xs:complexType>
+        <xs:sequence>
+          <xs:element ref="pc:TermInfo" minOccurs="0" maxOccurs="unbounded"/>
+        </xs:sequence>
+      </xs:complexType>
+    </xs:element>
+    <xs:element name="TermInfo">
+      <xs:complexType>
+        <xs:sequence>
+          <xs:element ref="pc:TermName" minOccurs="0"/>
+          <xs:element ref="pc:TermId" minOccurs="0"/>
+        </xs:sequence>
+      </xs:complexType>
+    </xs:element>
+    <xs:element name="TermName" type="xs:string"/>
+    <xs:element name="TermId" type="xs:string"/>
+  </xs:schema>
+</ct:contentTypeSchema>
+</file>
+
+<file path=ppt/customXml/item2.xml><?xml version="1.0" encoding="utf-8"?>
+<?mso-contentType ?>
+<FormTemplates xmlns="http://schemas.microsoft.com/sharepoint/v3/contenttype/forms">
+  <Display>DocumentLibraryForm</Display>
+  <Edit>DocumentLibraryForm</Edit>
+  <New>DocumentLibraryForm</New>
+</FormTemplates>
+</file>
+
+<file path=ppt/customXml/item3.xml><?xml version="1.0" encoding="utf-8"?>
+<p:properties xmlns:p="http://schemas.microsoft.com/office/2006/metadata/properties" xmlns:xsi="http://www.w3.org/2001/XMLSchema-instance" xmlns:pc="http://schemas.microsoft.com/office/infopath/2007/PartnerControls">
+  <documentManagement/>
+</p:properties>
+</file>
+
+<file path=ppt/customXml/itemProps1.xml><?xml version="1.0" encoding="utf-8"?>
+<ds:datastoreItem xmlns:ds="http://schemas.openxmlformats.org/officeDocument/2006/customXml" ds:itemID="{90543ACA-0080-4F1B-9A43-6D163ABF9D83}"/>
+</file>
+
+<file path=ppt/customXml/itemProps2.xml><?xml version="1.0" encoding="utf-8"?>
+<ds:datastoreItem xmlns:ds="http://schemas.openxmlformats.org/officeDocument/2006/customXml" ds:itemID="{421A96B9-6778-4816-9FBB-CD583C2BFA91}"/>
+</file>
+
+<file path=ppt/customXml/itemProps3.xml><?xml version="1.0" encoding="utf-8"?>
+<ds:datastoreItem xmlns:ds="http://schemas.openxmlformats.org/officeDocument/2006/customXml" ds:itemID="{554756CF-1238-4708-9A63-6FAA5836CF73}"/>
 </file>
 
 <file path=ppt/notesMasters/notesMaster1.xml><?xml version="1.0" encoding="utf-8"?>
@@ -508,7 +687,7 @@
         </p:nvSpPr>
         <p:spPr>
           <a:xfrm>
-            <a:off x="1524000" y="1122363"/>
+            <a:off x="1524000" y="1465263"/>
             <a:ext cx="9144000" cy="2387600"/>
           </a:xfrm>
         </p:spPr>
@@ -516,7 +695,7 @@
           <a:bodyPr anchor="b"/>
           <a:lstStyle>
             <a:lvl1pPr algn="ctr">
-              <a:defRPr sz="6000"/>
+              <a:defRPr sz="4800"/>
             </a:lvl1pPr>
           </a:lstStyle>
           <a:p>
@@ -545,7 +724,7 @@
         </p:nvSpPr>
         <p:spPr>
           <a:xfrm>
-            <a:off x="1524000" y="3602038"/>
+            <a:off x="1524000" y="3944938"/>
             <a:ext cx="9144000" cy="1655762"/>
           </a:xfrm>
         </p:spPr>
@@ -554,39 +733,39 @@
           <a:lstStyle>
             <a:lvl1pPr marL="0" indent="0" algn="ctr">
               <a:buNone/>
-              <a:defRPr sz="2400"/>
+              <a:defRPr sz="1920"/>
             </a:lvl1pPr>
             <a:lvl2pPr marL="457200" indent="0" algn="ctr">
               <a:buNone/>
-              <a:defRPr sz="2000"/>
+              <a:defRPr sz="1600"/>
             </a:lvl2pPr>
             <a:lvl3pPr marL="914400" indent="0" algn="ctr">
               <a:buNone/>
-              <a:defRPr sz="1800"/>
+              <a:defRPr sz="1440"/>
             </a:lvl3pPr>
             <a:lvl4pPr marL="1371600" indent="0" algn="ctr">
               <a:buNone/>
-              <a:defRPr sz="1600"/>
+              <a:defRPr sz="1280"/>
             </a:lvl4pPr>
             <a:lvl5pPr marL="1828800" indent="0" algn="ctr">
               <a:buNone/>
-              <a:defRPr sz="1600"/>
+              <a:defRPr sz="1280"/>
             </a:lvl5pPr>
             <a:lvl6pPr marL="2286000" indent="0" algn="ctr">
               <a:buNone/>
-              <a:defRPr sz="1600"/>
+              <a:defRPr sz="1280"/>
             </a:lvl6pPr>
             <a:lvl7pPr marL="2743200" indent="0" algn="ctr">
               <a:buNone/>
-              <a:defRPr sz="1600"/>
+              <a:defRPr sz="1280"/>
             </a:lvl7pPr>
             <a:lvl8pPr marL="3200400" indent="0" algn="ctr">
               <a:buNone/>
-              <a:defRPr sz="1600"/>
+              <a:defRPr sz="1280"/>
             </a:lvl8pPr>
             <a:lvl9pPr marL="3657600" indent="0" algn="ctr">
               <a:buNone/>
-              <a:defRPr sz="1600"/>
+              <a:defRPr sz="1280"/>
             </a:lvl9pPr>
           </a:lstStyle>
           <a:p>
@@ -651,35 +830,6 @@
               <a:rPr lang="en-US"/>
               <a:t>February 2, 2018</a:t>
             </a:r>
-          </a:p>
-        </p:txBody>
-      </p:sp>
-      <p:sp>
-        <p:nvSpPr>
-          <p:cNvPr id="6" name="Slide Number Placeholder 5">
-            <a:extLst>
-              <a:ext uri="{FF2B5EF4-FFF2-40B4-BE49-F238E27FC236}">
-                <a16:creationId xmlns:a16="http://schemas.microsoft.com/office/drawing/2014/main" id="{F904F53B-F57B-47C9-A92F-F7685BE8B0AD}"/>
-              </a:ext>
-            </a:extLst>
-          </p:cNvPr>
-          <p:cNvSpPr>
-            <a:spLocks noGrp="1"/>
-          </p:cNvSpPr>
-          <p:nvPr>
-            <p:ph type="sldNum" sz="quarter" idx="12"/>
-          </p:nvPr>
-        </p:nvSpPr>
-        <p:spPr/>
-        <p:txBody>
-          <a:bodyPr/>
-          <a:lstStyle/>
-          <a:p>
-            <a:fld id="{9B986996-2D1E-405B-9CF9-B8943C230E7D}" type="slidenum">
-              <a:rPr lang="en-US" smtClean="0"/>
-              <a:t>‹#›</a:t>
-            </a:fld>
-            <a:endParaRPr lang="en-US"/>
           </a:p>
         </p:txBody>
       </p:sp>
@@ -855,35 +1005,6 @@
           </a:p>
         </p:txBody>
       </p:sp>
-      <p:sp>
-        <p:nvSpPr>
-          <p:cNvPr id="6" name="Slide Number Placeholder 5">
-            <a:extLst>
-              <a:ext uri="{FF2B5EF4-FFF2-40B4-BE49-F238E27FC236}">
-                <a16:creationId xmlns:a16="http://schemas.microsoft.com/office/drawing/2014/main" id="{5CEEA5E7-C4AA-40A1-B21A-D45776CADB66}"/>
-              </a:ext>
-            </a:extLst>
-          </p:cNvPr>
-          <p:cNvSpPr>
-            <a:spLocks noGrp="1"/>
-          </p:cNvSpPr>
-          <p:nvPr>
-            <p:ph type="sldNum" sz="quarter" idx="12"/>
-          </p:nvPr>
-        </p:nvSpPr>
-        <p:spPr/>
-        <p:txBody>
-          <a:bodyPr/>
-          <a:lstStyle/>
-          <a:p>
-            <a:fld id="{9B986996-2D1E-405B-9CF9-B8943C230E7D}" type="slidenum">
-              <a:rPr lang="en-US" smtClean="0"/>
-              <a:t>‹#›</a:t>
-            </a:fld>
-            <a:endParaRPr lang="en-US"/>
-          </a:p>
-        </p:txBody>
-      </p:sp>
     </p:spTree>
     <p:extLst>
       <p:ext uri="{BB962C8B-B14F-4D97-AF65-F5344CB8AC3E}">
@@ -932,7 +1053,7 @@
         </p:nvSpPr>
         <p:spPr>
           <a:xfrm>
-            <a:off x="8724900" y="365125"/>
+            <a:off x="8724900" y="708025"/>
             <a:ext cx="2628900" cy="5811838"/>
           </a:xfrm>
         </p:spPr>
@@ -965,7 +1086,7 @@
         </p:nvSpPr>
         <p:spPr>
           <a:xfrm>
-            <a:off x="838200" y="365125"/>
+            <a:off x="838200" y="708025"/>
             <a:ext cx="7734300" cy="5811838"/>
           </a:xfrm>
         </p:spPr>
@@ -1063,35 +1184,6 @@
               <a:rPr lang="en-US"/>
               <a:t>February 2, 2018</a:t>
             </a:r>
-          </a:p>
-        </p:txBody>
-      </p:sp>
-      <p:sp>
-        <p:nvSpPr>
-          <p:cNvPr id="6" name="Slide Number Placeholder 5">
-            <a:extLst>
-              <a:ext uri="{FF2B5EF4-FFF2-40B4-BE49-F238E27FC236}">
-                <a16:creationId xmlns:a16="http://schemas.microsoft.com/office/drawing/2014/main" id="{C2B7D259-07C6-48B0-9254-6AD370EF9F50}"/>
-              </a:ext>
-            </a:extLst>
-          </p:cNvPr>
-          <p:cNvSpPr>
-            <a:spLocks noGrp="1"/>
-          </p:cNvSpPr>
-          <p:nvPr>
-            <p:ph type="sldNum" sz="quarter" idx="12"/>
-          </p:nvPr>
-        </p:nvSpPr>
-        <p:spPr/>
-        <p:txBody>
-          <a:bodyPr/>
-          <a:lstStyle/>
-          <a:p>
-            <a:fld id="{9B986996-2D1E-405B-9CF9-B8943C230E7D}" type="slidenum">
-              <a:rPr lang="en-US" smtClean="0"/>
-              <a:t>‹#›</a:t>
-            </a:fld>
-            <a:endParaRPr lang="en-US"/>
           </a:p>
         </p:txBody>
       </p:sp>
@@ -1267,35 +1359,6 @@
           </a:p>
         </p:txBody>
       </p:sp>
-      <p:sp>
-        <p:nvSpPr>
-          <p:cNvPr id="6" name="Slide Number Placeholder 5">
-            <a:extLst>
-              <a:ext uri="{FF2B5EF4-FFF2-40B4-BE49-F238E27FC236}">
-                <a16:creationId xmlns:a16="http://schemas.microsoft.com/office/drawing/2014/main" id="{AEA5D8E0-4006-4426-A11D-5700039C6F36}"/>
-              </a:ext>
-            </a:extLst>
-          </p:cNvPr>
-          <p:cNvSpPr>
-            <a:spLocks noGrp="1"/>
-          </p:cNvSpPr>
-          <p:nvPr>
-            <p:ph type="sldNum" sz="quarter" idx="12"/>
-          </p:nvPr>
-        </p:nvSpPr>
-        <p:spPr/>
-        <p:txBody>
-          <a:bodyPr/>
-          <a:lstStyle/>
-          <a:p>
-            <a:fld id="{9B986996-2D1E-405B-9CF9-B8943C230E7D}" type="slidenum">
-              <a:rPr lang="en-US" smtClean="0"/>
-              <a:t>‹#›</a:t>
-            </a:fld>
-            <a:endParaRPr lang="en-US"/>
-          </a:p>
-        </p:txBody>
-      </p:sp>
     </p:spTree>
     <p:extLst>
       <p:ext uri="{BB962C8B-B14F-4D97-AF65-F5344CB8AC3E}">
@@ -1344,7 +1407,7 @@
         </p:nvSpPr>
         <p:spPr>
           <a:xfrm>
-            <a:off x="831850" y="1709738"/>
+            <a:off x="831850" y="2052638"/>
             <a:ext cx="10515600" cy="2852737"/>
           </a:xfrm>
         </p:spPr>
@@ -1352,7 +1415,7 @@
           <a:bodyPr anchor="b"/>
           <a:lstStyle>
             <a:lvl1pPr>
-              <a:defRPr sz="6000"/>
+              <a:defRPr sz="4800"/>
             </a:lvl1pPr>
           </a:lstStyle>
           <a:p>
@@ -1381,7 +1444,7 @@
         </p:nvSpPr>
         <p:spPr>
           <a:xfrm>
-            <a:off x="831850" y="4589463"/>
+            <a:off x="831850" y="4932363"/>
             <a:ext cx="10515600" cy="1500187"/>
           </a:xfrm>
         </p:spPr>
@@ -1390,7 +1453,7 @@
           <a:lstStyle>
             <a:lvl1pPr marL="0" indent="0">
               <a:buNone/>
-              <a:defRPr sz="2400">
+              <a:defRPr sz="1920">
                 <a:solidFill>
                   <a:schemeClr val="tx1">
                     <a:tint val="75000"/>
@@ -1400,7 +1463,7 @@
             </a:lvl1pPr>
             <a:lvl2pPr marL="457200" indent="0">
               <a:buNone/>
-              <a:defRPr sz="2000">
+              <a:defRPr sz="1600">
                 <a:solidFill>
                   <a:schemeClr val="tx1">
                     <a:tint val="75000"/>
@@ -1410,7 +1473,7 @@
             </a:lvl2pPr>
             <a:lvl3pPr marL="914400" indent="0">
               <a:buNone/>
-              <a:defRPr sz="1800">
+              <a:defRPr sz="1440">
                 <a:solidFill>
                   <a:schemeClr val="tx1">
                     <a:tint val="75000"/>
@@ -1420,7 +1483,7 @@
             </a:lvl3pPr>
             <a:lvl4pPr marL="1371600" indent="0">
               <a:buNone/>
-              <a:defRPr sz="1600">
+              <a:defRPr sz="1280">
                 <a:solidFill>
                   <a:schemeClr val="tx1">
                     <a:tint val="75000"/>
@@ -1430,7 +1493,7 @@
             </a:lvl4pPr>
             <a:lvl5pPr marL="1828800" indent="0">
               <a:buNone/>
-              <a:defRPr sz="1600">
+              <a:defRPr sz="1280">
                 <a:solidFill>
                   <a:schemeClr val="tx1">
                     <a:tint val="75000"/>
@@ -1440,7 +1503,7 @@
             </a:lvl5pPr>
             <a:lvl6pPr marL="2286000" indent="0">
               <a:buNone/>
-              <a:defRPr sz="1600">
+              <a:defRPr sz="1280">
                 <a:solidFill>
                   <a:schemeClr val="tx1">
                     <a:tint val="75000"/>
@@ -1450,7 +1513,7 @@
             </a:lvl6pPr>
             <a:lvl7pPr marL="2743200" indent="0">
               <a:buNone/>
-              <a:defRPr sz="1600">
+              <a:defRPr sz="1280">
                 <a:solidFill>
                   <a:schemeClr val="tx1">
                     <a:tint val="75000"/>
@@ -1460,7 +1523,7 @@
             </a:lvl7pPr>
             <a:lvl8pPr marL="3200400" indent="0">
               <a:buNone/>
-              <a:defRPr sz="1600">
+              <a:defRPr sz="1280">
                 <a:solidFill>
                   <a:schemeClr val="tx1">
                     <a:tint val="75000"/>
@@ -1470,7 +1533,7 @@
             </a:lvl8pPr>
             <a:lvl9pPr marL="3657600" indent="0">
               <a:buNone/>
-              <a:defRPr sz="1600">
+              <a:defRPr sz="1280">
                 <a:solidFill>
                   <a:schemeClr val="tx1">
                     <a:tint val="75000"/>
@@ -1542,35 +1605,6 @@
               <a:rPr lang="en-US"/>
               <a:t>February 2, 2018</a:t>
             </a:r>
-          </a:p>
-        </p:txBody>
-      </p:sp>
-      <p:sp>
-        <p:nvSpPr>
-          <p:cNvPr id="6" name="Slide Number Placeholder 5">
-            <a:extLst>
-              <a:ext uri="{FF2B5EF4-FFF2-40B4-BE49-F238E27FC236}">
-                <a16:creationId xmlns:a16="http://schemas.microsoft.com/office/drawing/2014/main" id="{E1694650-6356-4EC4-81F5-07A87E9AFB88}"/>
-              </a:ext>
-            </a:extLst>
-          </p:cNvPr>
-          <p:cNvSpPr>
-            <a:spLocks noGrp="1"/>
-          </p:cNvSpPr>
-          <p:nvPr>
-            <p:ph type="sldNum" sz="quarter" idx="12"/>
-          </p:nvPr>
-        </p:nvSpPr>
-        <p:spPr/>
-        <p:txBody>
-          <a:bodyPr/>
-          <a:lstStyle/>
-          <a:p>
-            <a:fld id="{9B986996-2D1E-405B-9CF9-B8943C230E7D}" type="slidenum">
-              <a:rPr lang="en-US" smtClean="0"/>
-              <a:t>‹#›</a:t>
-            </a:fld>
-            <a:endParaRPr lang="en-US"/>
           </a:p>
         </p:txBody>
       </p:sp>
@@ -1650,7 +1684,7 @@
         </p:nvSpPr>
         <p:spPr>
           <a:xfrm>
-            <a:off x="838200" y="1825625"/>
+            <a:off x="838200" y="2168525"/>
             <a:ext cx="5181600" cy="4351338"/>
           </a:xfrm>
         </p:spPr>
@@ -1712,7 +1746,7 @@
         </p:nvSpPr>
         <p:spPr>
           <a:xfrm>
-            <a:off x="6172200" y="1825625"/>
+            <a:off x="6172200" y="2168525"/>
             <a:ext cx="5181600" cy="4351338"/>
           </a:xfrm>
         </p:spPr>
@@ -1810,35 +1844,6 @@
               <a:rPr lang="en-US"/>
               <a:t>February 2, 2018</a:t>
             </a:r>
-          </a:p>
-        </p:txBody>
-      </p:sp>
-      <p:sp>
-        <p:nvSpPr>
-          <p:cNvPr id="7" name="Slide Number Placeholder 6">
-            <a:extLst>
-              <a:ext uri="{FF2B5EF4-FFF2-40B4-BE49-F238E27FC236}">
-                <a16:creationId xmlns:a16="http://schemas.microsoft.com/office/drawing/2014/main" id="{E0E35762-F53B-44D7-A1CD-27E8CC789B91}"/>
-              </a:ext>
-            </a:extLst>
-          </p:cNvPr>
-          <p:cNvSpPr>
-            <a:spLocks noGrp="1"/>
-          </p:cNvSpPr>
-          <p:nvPr>
-            <p:ph type="sldNum" sz="quarter" idx="12"/>
-          </p:nvPr>
-        </p:nvSpPr>
-        <p:spPr/>
-        <p:txBody>
-          <a:bodyPr/>
-          <a:lstStyle/>
-          <a:p>
-            <a:fld id="{9B986996-2D1E-405B-9CF9-B8943C230E7D}" type="slidenum">
-              <a:rPr lang="en-US" smtClean="0"/>
-              <a:t>‹#›</a:t>
-            </a:fld>
-            <a:endParaRPr lang="en-US"/>
           </a:p>
         </p:txBody>
       </p:sp>
@@ -1890,7 +1895,7 @@
         </p:nvSpPr>
         <p:spPr>
           <a:xfrm>
-            <a:off x="839788" y="365125"/>
+            <a:off x="839788" y="708025"/>
             <a:ext cx="10515600" cy="1325563"/>
           </a:xfrm>
         </p:spPr>
@@ -1923,7 +1928,7 @@
         </p:nvSpPr>
         <p:spPr>
           <a:xfrm>
-            <a:off x="839788" y="1681163"/>
+            <a:off x="839788" y="2024063"/>
             <a:ext cx="5157787" cy="823912"/>
           </a:xfrm>
         </p:spPr>
@@ -1932,39 +1937,39 @@
           <a:lstStyle>
             <a:lvl1pPr marL="0" indent="0">
               <a:buNone/>
-              <a:defRPr sz="2400" b="1"/>
+              <a:defRPr sz="1920" b="1"/>
             </a:lvl1pPr>
             <a:lvl2pPr marL="457200" indent="0">
               <a:buNone/>
-              <a:defRPr sz="2000" b="1"/>
+              <a:defRPr sz="1600" b="1"/>
             </a:lvl2pPr>
             <a:lvl3pPr marL="914400" indent="0">
               <a:buNone/>
-              <a:defRPr sz="1800" b="1"/>
+              <a:defRPr sz="1440" b="1"/>
             </a:lvl3pPr>
             <a:lvl4pPr marL="1371600" indent="0">
               <a:buNone/>
-              <a:defRPr sz="1600" b="1"/>
+              <a:defRPr sz="1280" b="1"/>
             </a:lvl4pPr>
             <a:lvl5pPr marL="1828800" indent="0">
               <a:buNone/>
-              <a:defRPr sz="1600" b="1"/>
+              <a:defRPr sz="1280" b="1"/>
             </a:lvl5pPr>
             <a:lvl6pPr marL="2286000" indent="0">
               <a:buNone/>
-              <a:defRPr sz="1600" b="1"/>
+              <a:defRPr sz="1280" b="1"/>
             </a:lvl6pPr>
             <a:lvl7pPr marL="2743200" indent="0">
               <a:buNone/>
-              <a:defRPr sz="1600" b="1"/>
+              <a:defRPr sz="1280" b="1"/>
             </a:lvl7pPr>
             <a:lvl8pPr marL="3200400" indent="0">
               <a:buNone/>
-              <a:defRPr sz="1600" b="1"/>
+              <a:defRPr sz="1280" b="1"/>
             </a:lvl8pPr>
             <a:lvl9pPr marL="3657600" indent="0">
               <a:buNone/>
-              <a:defRPr sz="1600" b="1"/>
+              <a:defRPr sz="1280" b="1"/>
             </a:lvl9pPr>
           </a:lstStyle>
           <a:p>
@@ -1994,7 +1999,7 @@
         </p:nvSpPr>
         <p:spPr>
           <a:xfrm>
-            <a:off x="839788" y="2505075"/>
+            <a:off x="839788" y="2847975"/>
             <a:ext cx="5157787" cy="3684588"/>
           </a:xfrm>
         </p:spPr>
@@ -2056,7 +2061,7 @@
         </p:nvSpPr>
         <p:spPr>
           <a:xfrm>
-            <a:off x="6172200" y="1681163"/>
+            <a:off x="6172200" y="2024063"/>
             <a:ext cx="5183188" cy="823912"/>
           </a:xfrm>
         </p:spPr>
@@ -2065,39 +2070,39 @@
           <a:lstStyle>
             <a:lvl1pPr marL="0" indent="0">
               <a:buNone/>
-              <a:defRPr sz="2400" b="1"/>
+              <a:defRPr sz="1920" b="1"/>
             </a:lvl1pPr>
             <a:lvl2pPr marL="457200" indent="0">
               <a:buNone/>
-              <a:defRPr sz="2000" b="1"/>
+              <a:defRPr sz="1600" b="1"/>
             </a:lvl2pPr>
             <a:lvl3pPr marL="914400" indent="0">
               <a:buNone/>
-              <a:defRPr sz="1800" b="1"/>
+              <a:defRPr sz="1440" b="1"/>
             </a:lvl3pPr>
             <a:lvl4pPr marL="1371600" indent="0">
               <a:buNone/>
-              <a:defRPr sz="1600" b="1"/>
+              <a:defRPr sz="1280" b="1"/>
             </a:lvl4pPr>
             <a:lvl5pPr marL="1828800" indent="0">
               <a:buNone/>
-              <a:defRPr sz="1600" b="1"/>
+              <a:defRPr sz="1280" b="1"/>
             </a:lvl5pPr>
             <a:lvl6pPr marL="2286000" indent="0">
               <a:buNone/>
-              <a:defRPr sz="1600" b="1"/>
+              <a:defRPr sz="1280" b="1"/>
             </a:lvl6pPr>
             <a:lvl7pPr marL="2743200" indent="0">
               <a:buNone/>
-              <a:defRPr sz="1600" b="1"/>
+              <a:defRPr sz="1280" b="1"/>
             </a:lvl7pPr>
             <a:lvl8pPr marL="3200400" indent="0">
               <a:buNone/>
-              <a:defRPr sz="1600" b="1"/>
+              <a:defRPr sz="1280" b="1"/>
             </a:lvl8pPr>
             <a:lvl9pPr marL="3657600" indent="0">
               <a:buNone/>
-              <a:defRPr sz="1600" b="1"/>
+              <a:defRPr sz="1280" b="1"/>
             </a:lvl9pPr>
           </a:lstStyle>
           <a:p>
@@ -2127,7 +2132,7 @@
         </p:nvSpPr>
         <p:spPr>
           <a:xfrm>
-            <a:off x="6172200" y="2505075"/>
+            <a:off x="6172200" y="2847975"/>
             <a:ext cx="5183188" cy="3684588"/>
           </a:xfrm>
         </p:spPr>
@@ -2225,35 +2230,6 @@
               <a:rPr lang="en-US"/>
               <a:t>February 2, 2018</a:t>
             </a:r>
-          </a:p>
-        </p:txBody>
-      </p:sp>
-      <p:sp>
-        <p:nvSpPr>
-          <p:cNvPr id="9" name="Slide Number Placeholder 8">
-            <a:extLst>
-              <a:ext uri="{FF2B5EF4-FFF2-40B4-BE49-F238E27FC236}">
-                <a16:creationId xmlns:a16="http://schemas.microsoft.com/office/drawing/2014/main" id="{A8EB7274-0301-4B5A-8048-949FA2B6D784}"/>
-              </a:ext>
-            </a:extLst>
-          </p:cNvPr>
-          <p:cNvSpPr>
-            <a:spLocks noGrp="1"/>
-          </p:cNvSpPr>
-          <p:nvPr>
-            <p:ph type="sldNum" sz="quarter" idx="12"/>
-          </p:nvPr>
-        </p:nvSpPr>
-        <p:spPr/>
-        <p:txBody>
-          <a:bodyPr/>
-          <a:lstStyle/>
-          <a:p>
-            <a:fld id="{9B986996-2D1E-405B-9CF9-B8943C230E7D}" type="slidenum">
-              <a:rPr lang="en-US" smtClean="0"/>
-              <a:t>‹#›</a:t>
-            </a:fld>
-            <a:endParaRPr lang="en-US"/>
           </a:p>
         </p:txBody>
       </p:sp>
@@ -2372,35 +2348,6 @@
           </a:p>
         </p:txBody>
       </p:sp>
-      <p:sp>
-        <p:nvSpPr>
-          <p:cNvPr id="5" name="Slide Number Placeholder 4">
-            <a:extLst>
-              <a:ext uri="{FF2B5EF4-FFF2-40B4-BE49-F238E27FC236}">
-                <a16:creationId xmlns:a16="http://schemas.microsoft.com/office/drawing/2014/main" id="{17A7034F-90DC-4EFB-8ED4-AB673CBEFB1E}"/>
-              </a:ext>
-            </a:extLst>
-          </p:cNvPr>
-          <p:cNvSpPr>
-            <a:spLocks noGrp="1"/>
-          </p:cNvSpPr>
-          <p:nvPr>
-            <p:ph type="sldNum" sz="quarter" idx="12"/>
-          </p:nvPr>
-        </p:nvSpPr>
-        <p:spPr/>
-        <p:txBody>
-          <a:bodyPr/>
-          <a:lstStyle/>
-          <a:p>
-            <a:fld id="{9B986996-2D1E-405B-9CF9-B8943C230E7D}" type="slidenum">
-              <a:rPr lang="en-US" smtClean="0"/>
-              <a:t>‹#›</a:t>
-            </a:fld>
-            <a:endParaRPr lang="en-US"/>
-          </a:p>
-        </p:txBody>
-      </p:sp>
     </p:spTree>
     <p:extLst>
       <p:ext uri="{BB962C8B-B14F-4D97-AF65-F5344CB8AC3E}">
@@ -2488,35 +2435,6 @@
           </a:p>
         </p:txBody>
       </p:sp>
-      <p:sp>
-        <p:nvSpPr>
-          <p:cNvPr id="4" name="Slide Number Placeholder 3">
-            <a:extLst>
-              <a:ext uri="{FF2B5EF4-FFF2-40B4-BE49-F238E27FC236}">
-                <a16:creationId xmlns:a16="http://schemas.microsoft.com/office/drawing/2014/main" id="{950819DB-3991-4581-BFC1-791BE05C0D12}"/>
-              </a:ext>
-            </a:extLst>
-          </p:cNvPr>
-          <p:cNvSpPr>
-            <a:spLocks noGrp="1"/>
-          </p:cNvSpPr>
-          <p:nvPr>
-            <p:ph type="sldNum" sz="quarter" idx="12"/>
-          </p:nvPr>
-        </p:nvSpPr>
-        <p:spPr/>
-        <p:txBody>
-          <a:bodyPr/>
-          <a:lstStyle/>
-          <a:p>
-            <a:fld id="{9B986996-2D1E-405B-9CF9-B8943C230E7D}" type="slidenum">
-              <a:rPr lang="en-US" smtClean="0"/>
-              <a:t>‹#›</a:t>
-            </a:fld>
-            <a:endParaRPr lang="en-US"/>
-          </a:p>
-        </p:txBody>
-      </p:sp>
     </p:spTree>
     <p:extLst>
       <p:ext uri="{BB962C8B-B14F-4D97-AF65-F5344CB8AC3E}">
@@ -2565,7 +2483,7 @@
         </p:nvSpPr>
         <p:spPr>
           <a:xfrm>
-            <a:off x="839788" y="457200"/>
+            <a:off x="839788" y="800100"/>
             <a:ext cx="3932237" cy="1600200"/>
           </a:xfrm>
         </p:spPr>
@@ -2573,7 +2491,7 @@
           <a:bodyPr anchor="b"/>
           <a:lstStyle>
             <a:lvl1pPr>
-              <a:defRPr sz="3200"/>
+              <a:defRPr sz="2560"/>
             </a:lvl1pPr>
           </a:lstStyle>
           <a:p>
@@ -2602,7 +2520,7 @@
         </p:nvSpPr>
         <p:spPr>
           <a:xfrm>
-            <a:off x="5183188" y="987425"/>
+            <a:off x="5183188" y="1330325"/>
             <a:ext cx="6172200" cy="4873625"/>
           </a:xfrm>
         </p:spPr>
@@ -2610,31 +2528,31 @@
           <a:bodyPr/>
           <a:lstStyle>
             <a:lvl1pPr>
-              <a:defRPr sz="3200"/>
+              <a:defRPr sz="2560"/>
             </a:lvl1pPr>
             <a:lvl2pPr>
-              <a:defRPr sz="2800"/>
+              <a:defRPr sz="2240"/>
             </a:lvl2pPr>
             <a:lvl3pPr>
-              <a:defRPr sz="2400"/>
+              <a:defRPr sz="1920"/>
             </a:lvl3pPr>
             <a:lvl4pPr>
-              <a:defRPr sz="2000"/>
+              <a:defRPr sz="1600"/>
             </a:lvl4pPr>
             <a:lvl5pPr>
-              <a:defRPr sz="2000"/>
+              <a:defRPr sz="1600"/>
             </a:lvl5pPr>
             <a:lvl6pPr>
-              <a:defRPr sz="2000"/>
+              <a:defRPr sz="1600"/>
             </a:lvl6pPr>
             <a:lvl7pPr>
-              <a:defRPr sz="2000"/>
+              <a:defRPr sz="1600"/>
             </a:lvl7pPr>
             <a:lvl8pPr>
-              <a:defRPr sz="2000"/>
+              <a:defRPr sz="1600"/>
             </a:lvl8pPr>
             <a:lvl9pPr>
-              <a:defRPr sz="2000"/>
+              <a:defRPr sz="1600"/>
             </a:lvl9pPr>
           </a:lstStyle>
           <a:p>
@@ -2692,7 +2610,7 @@
         </p:nvSpPr>
         <p:spPr>
           <a:xfrm>
-            <a:off x="839788" y="2057400"/>
+            <a:off x="839788" y="2400300"/>
             <a:ext cx="3932237" cy="3811588"/>
           </a:xfrm>
         </p:spPr>
@@ -2701,39 +2619,39 @@
           <a:lstStyle>
             <a:lvl1pPr marL="0" indent="0">
               <a:buNone/>
-              <a:defRPr sz="1600"/>
+              <a:defRPr sz="1280"/>
             </a:lvl1pPr>
             <a:lvl2pPr marL="457200" indent="0">
               <a:buNone/>
-              <a:defRPr sz="1400"/>
+              <a:defRPr sz="1120"/>
             </a:lvl2pPr>
             <a:lvl3pPr marL="914400" indent="0">
               <a:buNone/>
-              <a:defRPr sz="1200"/>
+              <a:defRPr sz="960"/>
             </a:lvl3pPr>
             <a:lvl4pPr marL="1371600" indent="0">
               <a:buNone/>
-              <a:defRPr sz="1000"/>
+              <a:defRPr sz="800"/>
             </a:lvl4pPr>
             <a:lvl5pPr marL="1828800" indent="0">
               <a:buNone/>
-              <a:defRPr sz="1000"/>
+              <a:defRPr sz="800"/>
             </a:lvl5pPr>
             <a:lvl6pPr marL="2286000" indent="0">
               <a:buNone/>
-              <a:defRPr sz="1000"/>
+              <a:defRPr sz="800"/>
             </a:lvl6pPr>
             <a:lvl7pPr marL="2743200" indent="0">
               <a:buNone/>
-              <a:defRPr sz="1000"/>
+              <a:defRPr sz="800"/>
             </a:lvl7pPr>
             <a:lvl8pPr marL="3200400" indent="0">
               <a:buNone/>
-              <a:defRPr sz="1000"/>
+              <a:defRPr sz="800"/>
             </a:lvl8pPr>
             <a:lvl9pPr marL="3657600" indent="0">
               <a:buNone/>
-              <a:defRPr sz="1000"/>
+              <a:defRPr sz="800"/>
             </a:lvl9pPr>
           </a:lstStyle>
           <a:p>
@@ -2799,35 +2717,6 @@
               <a:rPr lang="en-US"/>
               <a:t>February 2, 2018</a:t>
             </a:r>
-          </a:p>
-        </p:txBody>
-      </p:sp>
-      <p:sp>
-        <p:nvSpPr>
-          <p:cNvPr id="7" name="Slide Number Placeholder 6">
-            <a:extLst>
-              <a:ext uri="{FF2B5EF4-FFF2-40B4-BE49-F238E27FC236}">
-                <a16:creationId xmlns:a16="http://schemas.microsoft.com/office/drawing/2014/main" id="{465DDE35-A4E7-47FF-980E-DA12DFE63137}"/>
-              </a:ext>
-            </a:extLst>
-          </p:cNvPr>
-          <p:cNvSpPr>
-            <a:spLocks noGrp="1"/>
-          </p:cNvSpPr>
-          <p:nvPr>
-            <p:ph type="sldNum" sz="quarter" idx="12"/>
-          </p:nvPr>
-        </p:nvSpPr>
-        <p:spPr/>
-        <p:txBody>
-          <a:bodyPr/>
-          <a:lstStyle/>
-          <a:p>
-            <a:fld id="{9B986996-2D1E-405B-9CF9-B8943C230E7D}" type="slidenum">
-              <a:rPr lang="en-US" smtClean="0"/>
-              <a:t>‹#›</a:t>
-            </a:fld>
-            <a:endParaRPr lang="en-US"/>
           </a:p>
         </p:txBody>
       </p:sp>
@@ -2879,7 +2768,7 @@
         </p:nvSpPr>
         <p:spPr>
           <a:xfrm>
-            <a:off x="839788" y="457200"/>
+            <a:off x="839788" y="800100"/>
             <a:ext cx="3932237" cy="1600200"/>
           </a:xfrm>
         </p:spPr>
@@ -2887,7 +2776,7 @@
           <a:bodyPr anchor="b"/>
           <a:lstStyle>
             <a:lvl1pPr>
-              <a:defRPr sz="3200"/>
+              <a:defRPr sz="2560"/>
             </a:lvl1pPr>
           </a:lstStyle>
           <a:p>
@@ -2916,7 +2805,7 @@
         </p:nvSpPr>
         <p:spPr>
           <a:xfrm>
-            <a:off x="5183188" y="987425"/>
+            <a:off x="5183188" y="1330325"/>
             <a:ext cx="6172200" cy="4873625"/>
           </a:xfrm>
         </p:spPr>
@@ -2925,39 +2814,39 @@
           <a:lstStyle>
             <a:lvl1pPr marL="0" indent="0">
               <a:buNone/>
-              <a:defRPr sz="3200"/>
+              <a:defRPr sz="2560"/>
             </a:lvl1pPr>
             <a:lvl2pPr marL="457200" indent="0">
               <a:buNone/>
-              <a:defRPr sz="2800"/>
+              <a:defRPr sz="2240"/>
             </a:lvl2pPr>
             <a:lvl3pPr marL="914400" indent="0">
               <a:buNone/>
-              <a:defRPr sz="2400"/>
+              <a:defRPr sz="1920"/>
             </a:lvl3pPr>
             <a:lvl4pPr marL="1371600" indent="0">
               <a:buNone/>
-              <a:defRPr sz="2000"/>
+              <a:defRPr sz="1600"/>
             </a:lvl4pPr>
             <a:lvl5pPr marL="1828800" indent="0">
               <a:buNone/>
-              <a:defRPr sz="2000"/>
+              <a:defRPr sz="1600"/>
             </a:lvl5pPr>
             <a:lvl6pPr marL="2286000" indent="0">
               <a:buNone/>
-              <a:defRPr sz="2000"/>
+              <a:defRPr sz="1600"/>
             </a:lvl6pPr>
             <a:lvl7pPr marL="2743200" indent="0">
               <a:buNone/>
-              <a:defRPr sz="2000"/>
+              <a:defRPr sz="1600"/>
             </a:lvl7pPr>
             <a:lvl8pPr marL="3200400" indent="0">
               <a:buNone/>
-              <a:defRPr sz="2000"/>
+              <a:defRPr sz="1600"/>
             </a:lvl8pPr>
             <a:lvl9pPr marL="3657600" indent="0">
               <a:buNone/>
-              <a:defRPr sz="2000"/>
+              <a:defRPr sz="1600"/>
             </a:lvl9pPr>
           </a:lstStyle>
           <a:p>
@@ -2983,7 +2872,7 @@
         </p:nvSpPr>
         <p:spPr>
           <a:xfrm>
-            <a:off x="839788" y="2057400"/>
+            <a:off x="839788" y="2400300"/>
             <a:ext cx="3932237" cy="3811588"/>
           </a:xfrm>
         </p:spPr>
@@ -2992,39 +2881,39 @@
           <a:lstStyle>
             <a:lvl1pPr marL="0" indent="0">
               <a:buNone/>
-              <a:defRPr sz="1600"/>
+              <a:defRPr sz="1280"/>
             </a:lvl1pPr>
             <a:lvl2pPr marL="457200" indent="0">
               <a:buNone/>
-              <a:defRPr sz="1400"/>
+              <a:defRPr sz="1120"/>
             </a:lvl2pPr>
             <a:lvl3pPr marL="914400" indent="0">
               <a:buNone/>
-              <a:defRPr sz="1200"/>
+              <a:defRPr sz="960"/>
             </a:lvl3pPr>
             <a:lvl4pPr marL="1371600" indent="0">
               <a:buNone/>
-              <a:defRPr sz="1000"/>
+              <a:defRPr sz="800"/>
             </a:lvl4pPr>
             <a:lvl5pPr marL="1828800" indent="0">
               <a:buNone/>
-              <a:defRPr sz="1000"/>
+              <a:defRPr sz="800"/>
             </a:lvl5pPr>
             <a:lvl6pPr marL="2286000" indent="0">
               <a:buNone/>
-              <a:defRPr sz="1000"/>
+              <a:defRPr sz="800"/>
             </a:lvl6pPr>
             <a:lvl7pPr marL="2743200" indent="0">
               <a:buNone/>
-              <a:defRPr sz="1000"/>
+              <a:defRPr sz="800"/>
             </a:lvl7pPr>
             <a:lvl8pPr marL="3200400" indent="0">
               <a:buNone/>
-              <a:defRPr sz="1000"/>
+              <a:defRPr sz="800"/>
             </a:lvl8pPr>
             <a:lvl9pPr marL="3657600" indent="0">
               <a:buNone/>
-              <a:defRPr sz="1000"/>
+              <a:defRPr sz="800"/>
             </a:lvl9pPr>
           </a:lstStyle>
           <a:p>
@@ -3090,35 +2979,6 @@
               <a:rPr lang="en-US"/>
               <a:t>February 2, 2018</a:t>
             </a:r>
-          </a:p>
-        </p:txBody>
-      </p:sp>
-      <p:sp>
-        <p:nvSpPr>
-          <p:cNvPr id="7" name="Slide Number Placeholder 6">
-            <a:extLst>
-              <a:ext uri="{FF2B5EF4-FFF2-40B4-BE49-F238E27FC236}">
-                <a16:creationId xmlns:a16="http://schemas.microsoft.com/office/drawing/2014/main" id="{7352309F-7FEA-4C8C-B7E8-F77219D281D9}"/>
-              </a:ext>
-            </a:extLst>
-          </p:cNvPr>
-          <p:cNvSpPr>
-            <a:spLocks noGrp="1"/>
-          </p:cNvSpPr>
-          <p:nvPr>
-            <p:ph type="sldNum" sz="quarter" idx="12"/>
-          </p:nvPr>
-        </p:nvSpPr>
-        <p:spPr/>
-        <p:txBody>
-          <a:bodyPr/>
-          <a:lstStyle/>
-          <a:p>
-            <a:fld id="{9B986996-2D1E-405B-9CF9-B8943C230E7D}" type="slidenum">
-              <a:rPr lang="en-US" smtClean="0"/>
-              <a:t>‹#›</a:t>
-            </a:fld>
-            <a:endParaRPr lang="en-US"/>
           </a:p>
         </p:txBody>
       </p:sp>
@@ -3175,7 +3035,7 @@
         </p:nvSpPr>
         <p:spPr>
           <a:xfrm>
-            <a:off x="838200" y="365125"/>
+            <a:off x="838200" y="708025"/>
             <a:ext cx="10515600" cy="1325563"/>
           </a:xfrm>
           <a:prstGeom prst="rect">
@@ -3213,7 +3073,7 @@
         </p:nvSpPr>
         <p:spPr>
           <a:xfrm>
-            <a:off x="838200" y="1825625"/>
+            <a:off x="838200" y="2168525"/>
             <a:ext cx="10515600" cy="4351338"/>
           </a:xfrm>
           <a:prstGeom prst="rect">
@@ -3280,7 +3140,7 @@
         </p:nvSpPr>
         <p:spPr>
           <a:xfrm>
-            <a:off x="838200" y="6356350"/>
+            <a:off x="838200" y="6699250"/>
             <a:ext cx="2743200" cy="365125"/>
           </a:xfrm>
           <a:prstGeom prst="rect">
@@ -3291,7 +3151,7 @@
           <a:bodyPr vert="horz" lIns="91440" tIns="45720" rIns="91440" bIns="45720" rtlCol="0" anchor="ctr"/>
           <a:lstStyle>
             <a:lvl1pPr algn="l">
-              <a:defRPr sz="1200">
+              <a:defRPr sz="960">
                 <a:solidFill>
                   <a:schemeClr val="tx1">
                     <a:tint val="75000"/>
@@ -3327,7 +3187,7 @@
         </p:nvSpPr>
         <p:spPr>
           <a:xfrm>
-            <a:off x="4038600" y="6356350"/>
+            <a:off x="4038600" y="6699250"/>
             <a:ext cx="4114800" cy="365125"/>
           </a:xfrm>
           <a:prstGeom prst="rect">
@@ -3338,7 +3198,7 @@
           <a:bodyPr vert="horz" lIns="91440" tIns="45720" rIns="91440" bIns="45720" rtlCol="0" anchor="ctr"/>
           <a:lstStyle>
             <a:lvl1pPr algn="ctr">
-              <a:defRPr sz="1200">
+              <a:defRPr sz="960">
                 <a:solidFill>
                   <a:schemeClr val="tx1">
                     <a:tint val="75000"/>
@@ -3352,53 +3212,6 @@
               <a:rPr lang="en-US"/>
               <a:t>February 2, 2018</a:t>
             </a:r>
-          </a:p>
-        </p:txBody>
-      </p:sp>
-      <p:sp>
-        <p:nvSpPr>
-          <p:cNvPr id="6" name="Slide Number Placeholder 5">
-            <a:extLst>
-              <a:ext uri="{FF2B5EF4-FFF2-40B4-BE49-F238E27FC236}">
-                <a16:creationId xmlns:a16="http://schemas.microsoft.com/office/drawing/2014/main" id="{ED8F698C-8D92-4A9D-91DD-CAE96F50A64D}"/>
-              </a:ext>
-            </a:extLst>
-          </p:cNvPr>
-          <p:cNvSpPr>
-            <a:spLocks noGrp="1"/>
-          </p:cNvSpPr>
-          <p:nvPr>
-            <p:ph type="sldNum" sz="quarter" idx="4"/>
-          </p:nvPr>
-        </p:nvSpPr>
-        <p:spPr>
-          <a:xfrm>
-            <a:off x="8610600" y="6356350"/>
-            <a:ext cx="2743200" cy="365125"/>
-          </a:xfrm>
-          <a:prstGeom prst="rect">
-            <a:avLst/>
-          </a:prstGeom>
-        </p:spPr>
-        <p:txBody>
-          <a:bodyPr vert="horz" lIns="91440" tIns="45720" rIns="91440" bIns="45720" rtlCol="0" anchor="ctr"/>
-          <a:lstStyle>
-            <a:lvl1pPr algn="r">
-              <a:defRPr sz="1200">
-                <a:solidFill>
-                  <a:schemeClr val="tx1">
-                    <a:tint val="75000"/>
-                  </a:schemeClr>
-                </a:solidFill>
-              </a:defRPr>
-            </a:lvl1pPr>
-          </a:lstStyle>
-          <a:p>
-            <a:fld id="{9B986996-2D1E-405B-9CF9-B8943C230E7D}" type="slidenum">
-              <a:rPr lang="en-US" smtClean="0"/>
-              <a:t>‹#›</a:t>
-            </a:fld>
-            <a:endParaRPr lang="en-US"/>
           </a:p>
         </p:txBody>
       </p:sp>
@@ -3434,11 +3247,11 @@
           <a:spcPct val="0"/>
         </a:spcBef>
         <a:buNone/>
-        <a:defRPr sz="4400" kern="1200">
+        <a:defRPr sz="3520" kern="1200">
           <a:solidFill>
             <a:schemeClr val="tx1"/>
           </a:solidFill>
-          <a:latin typeface="+mj-lt"/>
+          <a:latin typeface="Arial"/>
           <a:ea typeface="+mj-ea"/>
           <a:cs typeface="+mj-cs"/>
         </a:defRPr>
@@ -3454,11 +3267,11 @@
         </a:spcBef>
         <a:buFont typeface="Arial" panose="020B0604020202020204" pitchFamily="34" charset="0"/>
         <a:buChar char="•"/>
-        <a:defRPr sz="2800" kern="1200">
+        <a:defRPr sz="2240" kern="1200">
           <a:solidFill>
             <a:schemeClr val="tx1"/>
           </a:solidFill>
-          <a:latin typeface="+mn-lt"/>
+          <a:latin typeface="Arial"/>
           <a:ea typeface="+mn-ea"/>
           <a:cs typeface="+mn-cs"/>
         </a:defRPr>
@@ -3472,11 +3285,11 @@
         </a:spcBef>
         <a:buFont typeface="Arial" panose="020B0604020202020204" pitchFamily="34" charset="0"/>
         <a:buChar char="•"/>
-        <a:defRPr sz="2400" kern="1200">
+        <a:defRPr sz="1920" kern="1200">
           <a:solidFill>
             <a:schemeClr val="tx1"/>
           </a:solidFill>
-          <a:latin typeface="+mn-lt"/>
+          <a:latin typeface="Arial"/>
           <a:ea typeface="+mn-ea"/>
           <a:cs typeface="+mn-cs"/>
         </a:defRPr>
@@ -3490,11 +3303,11 @@
         </a:spcBef>
         <a:buFont typeface="Arial" panose="020B0604020202020204" pitchFamily="34" charset="0"/>
         <a:buChar char="•"/>
-        <a:defRPr sz="2000" kern="1200">
+        <a:defRPr sz="1600" kern="1200">
           <a:solidFill>
             <a:schemeClr val="tx1"/>
           </a:solidFill>
-          <a:latin typeface="+mn-lt"/>
+          <a:latin typeface="Arial"/>
           <a:ea typeface="+mn-ea"/>
           <a:cs typeface="+mn-cs"/>
         </a:defRPr>
@@ -3508,11 +3321,11 @@
         </a:spcBef>
         <a:buFont typeface="Arial" panose="020B0604020202020204" pitchFamily="34" charset="0"/>
         <a:buChar char="•"/>
-        <a:defRPr sz="1800" kern="1200">
+        <a:defRPr sz="1440" kern="1200">
           <a:solidFill>
             <a:schemeClr val="tx1"/>
           </a:solidFill>
-          <a:latin typeface="+mn-lt"/>
+          <a:latin typeface="Arial"/>
           <a:ea typeface="+mn-ea"/>
           <a:cs typeface="+mn-cs"/>
         </a:defRPr>
@@ -3526,11 +3339,11 @@
         </a:spcBef>
         <a:buFont typeface="Arial" panose="020B0604020202020204" pitchFamily="34" charset="0"/>
         <a:buChar char="•"/>
-        <a:defRPr sz="1800" kern="1200">
+        <a:defRPr sz="1440" kern="1200">
           <a:solidFill>
             <a:schemeClr val="tx1"/>
           </a:solidFill>
-          <a:latin typeface="+mn-lt"/>
+          <a:latin typeface="Arial"/>
           <a:ea typeface="+mn-ea"/>
           <a:cs typeface="+mn-cs"/>
         </a:defRPr>
@@ -3544,11 +3357,11 @@
         </a:spcBef>
         <a:buFont typeface="Arial" panose="020B0604020202020204" pitchFamily="34" charset="0"/>
         <a:buChar char="•"/>
-        <a:defRPr sz="1800" kern="1200">
+        <a:defRPr sz="1440" kern="1200">
           <a:solidFill>
             <a:schemeClr val="tx1"/>
           </a:solidFill>
-          <a:latin typeface="+mn-lt"/>
+          <a:latin typeface="Arial"/>
           <a:ea typeface="+mn-ea"/>
           <a:cs typeface="+mn-cs"/>
         </a:defRPr>
@@ -3562,11 +3375,11 @@
         </a:spcBef>
         <a:buFont typeface="Arial" panose="020B0604020202020204" pitchFamily="34" charset="0"/>
         <a:buChar char="•"/>
-        <a:defRPr sz="1800" kern="1200">
+        <a:defRPr sz="1440" kern="1200">
           <a:solidFill>
             <a:schemeClr val="tx1"/>
           </a:solidFill>
-          <a:latin typeface="+mn-lt"/>
+          <a:latin typeface="Arial"/>
           <a:ea typeface="+mn-ea"/>
           <a:cs typeface="+mn-cs"/>
         </a:defRPr>
@@ -3580,11 +3393,11 @@
         </a:spcBef>
         <a:buFont typeface="Arial" panose="020B0604020202020204" pitchFamily="34" charset="0"/>
         <a:buChar char="•"/>
-        <a:defRPr sz="1800" kern="1200">
+        <a:defRPr sz="1440" kern="1200">
           <a:solidFill>
             <a:schemeClr val="tx1"/>
           </a:solidFill>
-          <a:latin typeface="+mn-lt"/>
+          <a:latin typeface="Arial"/>
           <a:ea typeface="+mn-ea"/>
           <a:cs typeface="+mn-cs"/>
         </a:defRPr>
@@ -3598,11 +3411,11 @@
         </a:spcBef>
         <a:buFont typeface="Arial" panose="020B0604020202020204" pitchFamily="34" charset="0"/>
         <a:buChar char="•"/>
-        <a:defRPr sz="1800" kern="1200">
+        <a:defRPr sz="1440" kern="1200">
           <a:solidFill>
             <a:schemeClr val="tx1"/>
           </a:solidFill>
-          <a:latin typeface="+mn-lt"/>
+          <a:latin typeface="Arial"/>
           <a:ea typeface="+mn-ea"/>
           <a:cs typeface="+mn-cs"/>
         </a:defRPr>
@@ -3613,91 +3426,91 @@
         <a:defRPr lang="en-US"/>
       </a:defPPr>
       <a:lvl1pPr marL="0" algn="l" defTabSz="914400" rtl="0" eaLnBrk="1" latinLnBrk="0" hangingPunct="1">
-        <a:defRPr sz="1800" kern="1200">
+        <a:defRPr sz="1440" kern="1200">
           <a:solidFill>
             <a:schemeClr val="tx1"/>
           </a:solidFill>
-          <a:latin typeface="+mn-lt"/>
+          <a:latin typeface="Arial"/>
           <a:ea typeface="+mn-ea"/>
           <a:cs typeface="+mn-cs"/>
         </a:defRPr>
       </a:lvl1pPr>
       <a:lvl2pPr marL="457200" algn="l" defTabSz="914400" rtl="0" eaLnBrk="1" latinLnBrk="0" hangingPunct="1">
-        <a:defRPr sz="1800" kern="1200">
+        <a:defRPr sz="1440" kern="1200">
           <a:solidFill>
             <a:schemeClr val="tx1"/>
           </a:solidFill>
-          <a:latin typeface="+mn-lt"/>
+          <a:latin typeface="Arial"/>
           <a:ea typeface="+mn-ea"/>
           <a:cs typeface="+mn-cs"/>
         </a:defRPr>
       </a:lvl2pPr>
       <a:lvl3pPr marL="914400" algn="l" defTabSz="914400" rtl="0" eaLnBrk="1" latinLnBrk="0" hangingPunct="1">
-        <a:defRPr sz="1800" kern="1200">
+        <a:defRPr sz="1440" kern="1200">
           <a:solidFill>
             <a:schemeClr val="tx1"/>
           </a:solidFill>
-          <a:latin typeface="+mn-lt"/>
+          <a:latin typeface="Arial"/>
           <a:ea typeface="+mn-ea"/>
           <a:cs typeface="+mn-cs"/>
         </a:defRPr>
       </a:lvl3pPr>
       <a:lvl4pPr marL="1371600" algn="l" defTabSz="914400" rtl="0" eaLnBrk="1" latinLnBrk="0" hangingPunct="1">
-        <a:defRPr sz="1800" kern="1200">
+        <a:defRPr sz="1440" kern="1200">
           <a:solidFill>
             <a:schemeClr val="tx1"/>
           </a:solidFill>
-          <a:latin typeface="+mn-lt"/>
+          <a:latin typeface="Arial"/>
           <a:ea typeface="+mn-ea"/>
           <a:cs typeface="+mn-cs"/>
         </a:defRPr>
       </a:lvl4pPr>
       <a:lvl5pPr marL="1828800" algn="l" defTabSz="914400" rtl="0" eaLnBrk="1" latinLnBrk="0" hangingPunct="1">
-        <a:defRPr sz="1800" kern="1200">
+        <a:defRPr sz="1440" kern="1200">
           <a:solidFill>
             <a:schemeClr val="tx1"/>
           </a:solidFill>
-          <a:latin typeface="+mn-lt"/>
+          <a:latin typeface="Arial"/>
           <a:ea typeface="+mn-ea"/>
           <a:cs typeface="+mn-cs"/>
         </a:defRPr>
       </a:lvl5pPr>
       <a:lvl6pPr marL="2286000" algn="l" defTabSz="914400" rtl="0" eaLnBrk="1" latinLnBrk="0" hangingPunct="1">
-        <a:defRPr sz="1800" kern="1200">
+        <a:defRPr sz="1440" kern="1200">
           <a:solidFill>
             <a:schemeClr val="tx1"/>
           </a:solidFill>
-          <a:latin typeface="+mn-lt"/>
+          <a:latin typeface="Arial"/>
           <a:ea typeface="+mn-ea"/>
           <a:cs typeface="+mn-cs"/>
         </a:defRPr>
       </a:lvl6pPr>
       <a:lvl7pPr marL="2743200" algn="l" defTabSz="914400" rtl="0" eaLnBrk="1" latinLnBrk="0" hangingPunct="1">
-        <a:defRPr sz="1800" kern="1200">
+        <a:defRPr sz="1440" kern="1200">
           <a:solidFill>
             <a:schemeClr val="tx1"/>
           </a:solidFill>
-          <a:latin typeface="+mn-lt"/>
+          <a:latin typeface="Arial"/>
           <a:ea typeface="+mn-ea"/>
           <a:cs typeface="+mn-cs"/>
         </a:defRPr>
       </a:lvl7pPr>
       <a:lvl8pPr marL="3200400" algn="l" defTabSz="914400" rtl="0" eaLnBrk="1" latinLnBrk="0" hangingPunct="1">
-        <a:defRPr sz="1800" kern="1200">
+        <a:defRPr sz="1440" kern="1200">
           <a:solidFill>
             <a:schemeClr val="tx1"/>
           </a:solidFill>
-          <a:latin typeface="+mn-lt"/>
+          <a:latin typeface="Arial"/>
           <a:ea typeface="+mn-ea"/>
           <a:cs typeface="+mn-cs"/>
         </a:defRPr>
       </a:lvl8pPr>
       <a:lvl9pPr marL="3657600" algn="l" defTabSz="914400" rtl="0" eaLnBrk="1" latinLnBrk="0" hangingPunct="1">
-        <a:defRPr sz="1800" kern="1200">
+        <a:defRPr sz="1440" kern="1200">
           <a:solidFill>
             <a:schemeClr val="tx1"/>
           </a:solidFill>
-          <a:latin typeface="+mn-lt"/>
+          <a:latin typeface="Arial"/>
           <a:ea typeface="+mn-ea"/>
           <a:cs typeface="+mn-cs"/>
         </a:defRPr>
@@ -3808,30 +3621,202 @@
       </p:sp>
       <p:sp>
         <p:nvSpPr>
-          <p:cNvPr id="7" name="Slide Number Placeholder 6">
-            <a:extLst>
-              <a:ext uri="{FF2B5EF4-FFF2-40B4-BE49-F238E27FC236}">
-                <a16:creationId xmlns:a16="http://schemas.microsoft.com/office/drawing/2014/main" id="{8511CC50-D61E-4EC4-BB8E-0E19AB1B0129}"/>
-              </a:ext>
-            </a:extLst>
-          </p:cNvPr>
-          <p:cNvSpPr>
-            <a:spLocks noGrp="1"/>
-          </p:cNvSpPr>
-          <p:nvPr>
-            <p:ph type="sldNum" sz="quarter" idx="12"/>
-          </p:nvPr>
-        </p:nvSpPr>
-        <p:spPr/>
-        <p:txBody>
-          <a:bodyPr/>
-          <a:lstStyle/>
-          <a:p>
-            <a:fld id="{9B986996-2D1E-405B-9CF9-B8943C230E7D}" type="slidenum">
-              <a:rPr lang="en-US" smtClean="0"/>
-              <a:t>1</a:t>
-            </a:fld>
-            <a:endParaRPr lang="en-US"/>
+          <p:cNvPr id="7" name="DSPIRA 1"/>
+          <p:cNvSpPr>
+            <a:spLocks noGrp="1"/>
+          </p:cNvSpPr>
+          <p:nvPr/>
+        </p:nvSpPr>
+        <p:spPr>
+          <a:xfrm>
+            <a:off x="0" y="0"/>
+            <a:ext cx="12192000" cy="342900"/>
+          </a:xfrm>
+          <a:prstGeom prst="rect">
+            <a:avLst/>
+          </a:prstGeom>
+          <a:solidFill>
+            <a:srgbClr val="FFFFFF"/>
+          </a:solidFill>
+          <a:ln w="0">
+            <a:noFill/>
+          </a:ln>
+        </p:spPr>
+      </p:sp>
+      <p:sp>
+        <p:nvSpPr>
+          <p:cNvPr id="8" name="DSPIRA 2"/>
+          <p:cNvSpPr>
+            <a:spLocks noGrp="1"/>
+          </p:cNvSpPr>
+          <p:nvPr/>
+        </p:nvSpPr>
+        <p:spPr>
+          <a:xfrm>
+            <a:off x="0" y="7200900"/>
+            <a:ext cx="12192000" cy="342900"/>
+          </a:xfrm>
+          <a:prstGeom prst="rect">
+            <a:avLst/>
+          </a:prstGeom>
+          <a:solidFill>
+            <a:srgbClr val="FFFFFF"/>
+          </a:solidFill>
+          <a:ln w="0">
+            <a:noFill/>
+          </a:ln>
+        </p:spPr>
+      </p:sp>
+      <p:sp>
+        <p:nvSpPr>
+          <p:cNvPr id="9" name="DSPIRA 3"/>
+          <p:cNvSpPr>
+            <a:spLocks noGrp="1"/>
+          </p:cNvSpPr>
+          <p:nvPr/>
+        </p:nvSpPr>
+        <p:spPr>
+          <a:xfrm>
+            <a:off x="228600" y="76200"/>
+            <a:ext cx="4762500" cy="228600"/>
+          </a:xfrm>
+          <a:prstGeom prst="rect">
+            <a:avLst/>
+          </a:prstGeom>
+          <a:noFill/>
+          <a:ln w="0">
+            <a:noFill/>
+          </a:ln>
+        </p:spPr>
+        <p:txBody>
+          <a:bodyPr>
+            <a:noAutofit/>
+          </a:bodyPr>
+          <a:lstStyle/>
+          <a:p>
+            <a:pPr>
+              <a:defRPr sz="1200" b="1">
+                <a:solidFill>
+                  <a:srgbClr val="002855"/>
+                </a:solidFill>
+                <a:latin typeface="Arial"/>
+                <a:ea typeface="Arial"/>
+                <a:cs typeface="Arial"/>
+              </a:defRPr>
+            </a:pPr>
+            <a:r>
+              <a:rPr sz="1200" b="1">
+                <a:solidFill>
+                  <a:srgbClr val="002855"/>
+                </a:solidFill>
+                <a:latin typeface="Arial"/>
+                <a:ea typeface="Arial"/>
+                <a:cs typeface="Arial"/>
+              </a:rPr>
+              <a:t>WVU DSPIRA</a:t>
+            </a:r>
+          </a:p>
+        </p:txBody>
+      </p:sp>
+      <p:sp>
+        <p:nvSpPr>
+          <p:cNvPr id="10" name="DSPIRA 4"/>
+          <p:cNvSpPr>
+            <a:spLocks noGrp="1"/>
+          </p:cNvSpPr>
+          <p:nvPr/>
+        </p:nvSpPr>
+        <p:spPr>
+          <a:xfrm>
+            <a:off x="228600" y="7277100"/>
+            <a:ext cx="6667500" cy="228600"/>
+          </a:xfrm>
+          <a:prstGeom prst="rect">
+            <a:avLst/>
+          </a:prstGeom>
+          <a:noFill/>
+          <a:ln w="0">
+            <a:noFill/>
+          </a:ln>
+        </p:spPr>
+        <p:txBody>
+          <a:bodyPr>
+            <a:noAutofit/>
+          </a:bodyPr>
+          <a:lstStyle/>
+          <a:p>
+            <a:pPr>
+              <a:defRPr sz="900" b="0">
+                <a:solidFill>
+                  <a:srgbClr val="002855"/>
+                </a:solidFill>
+                <a:latin typeface="Arial"/>
+                <a:ea typeface="Arial"/>
+                <a:cs typeface="Arial"/>
+              </a:defRPr>
+            </a:pPr>
+            <a:r>
+              <a:rPr sz="900" b="0">
+                <a:solidFill>
+                  <a:srgbClr val="002855"/>
+                </a:solidFill>
+                <a:latin typeface="Arial"/>
+                <a:ea typeface="Arial"/>
+                <a:cs typeface="Arial"/>
+              </a:rPr>
+              <a:t>wvurail.org/dspira</a:t>
+            </a:r>
+          </a:p>
+        </p:txBody>
+      </p:sp>
+      <p:sp>
+        <p:nvSpPr>
+          <p:cNvPr id="11" name="DSPIRA 5"/>
+          <p:cNvSpPr>
+            <a:spLocks noGrp="1"/>
+          </p:cNvSpPr>
+          <p:nvPr/>
+        </p:nvSpPr>
+        <p:spPr>
+          <a:xfrm>
+            <a:off x="11191875" y="7277100"/>
+            <a:ext cx="762000" cy="228600"/>
+          </a:xfrm>
+          <a:prstGeom prst="rect">
+            <a:avLst/>
+          </a:prstGeom>
+          <a:noFill/>
+          <a:ln w="0">
+            <a:noFill/>
+          </a:ln>
+        </p:spPr>
+        <p:txBody>
+          <a:bodyPr>
+            <a:noAutofit/>
+          </a:bodyPr>
+          <a:lstStyle/>
+          <a:p>
+            <a:pPr>
+              <a:defRPr sz="900" b="0">
+                <a:solidFill>
+                  <a:srgbClr val="002855"/>
+                </a:solidFill>
+                <a:latin typeface="Arial"/>
+                <a:ea typeface="Arial"/>
+                <a:cs typeface="Arial"/>
+              </a:defRPr>
+            </a:pPr>
+            <a:r>
+              <a:rPr sz="900" b="0">
+                <a:solidFill>
+                  <a:srgbClr val="002855"/>
+                </a:solidFill>
+                <a:latin typeface="Arial"/>
+                <a:ea typeface="Arial"/>
+                <a:cs typeface="Arial"/>
+              </a:rPr>
+              <a:t>1 of 11</a:t>
+            </a:r>
           </a:p>
         </p:txBody>
       </p:sp>
@@ -3883,7 +3868,7 @@
         </p:nvSpPr>
         <p:spPr>
           <a:xfrm>
-            <a:off x="838200" y="365126"/>
+            <a:off x="838200" y="708026"/>
             <a:ext cx="10515600" cy="1088668"/>
           </a:xfrm>
         </p:spPr>
@@ -3923,35 +3908,6 @@
               <a:rPr lang="en-US"/>
               <a:t>February 2, 2018</a:t>
             </a:r>
-          </a:p>
-        </p:txBody>
-      </p:sp>
-      <p:sp>
-        <p:nvSpPr>
-          <p:cNvPr id="4" name="Slide Number Placeholder 3">
-            <a:extLst>
-              <a:ext uri="{FF2B5EF4-FFF2-40B4-BE49-F238E27FC236}">
-                <a16:creationId xmlns:a16="http://schemas.microsoft.com/office/drawing/2014/main" id="{FD9D5D87-3138-4AEE-A822-6D2341E3FE1B}"/>
-              </a:ext>
-            </a:extLst>
-          </p:cNvPr>
-          <p:cNvSpPr>
-            <a:spLocks noGrp="1"/>
-          </p:cNvSpPr>
-          <p:nvPr>
-            <p:ph type="sldNum" sz="quarter" idx="12"/>
-          </p:nvPr>
-        </p:nvSpPr>
-        <p:spPr/>
-        <p:txBody>
-          <a:bodyPr/>
-          <a:lstStyle/>
-          <a:p>
-            <a:fld id="{9B986996-2D1E-405B-9CF9-B8943C230E7D}" type="slidenum">
-              <a:rPr lang="en-US" smtClean="0"/>
-              <a:t>10</a:t>
-            </a:fld>
-            <a:endParaRPr lang="en-US"/>
           </a:p>
         </p:txBody>
       </p:sp>
@@ -3983,7 +3939,7 @@
         </p:blipFill>
         <p:spPr>
           <a:xfrm>
-            <a:off x="325040" y="1453793"/>
+            <a:off x="325040" y="1796693"/>
             <a:ext cx="5577463" cy="4292122"/>
           </a:xfrm>
           <a:prstGeom prst="rect">
@@ -4019,7 +3975,7 @@
         </p:blipFill>
         <p:spPr>
           <a:xfrm>
-            <a:off x="5853393" y="1453793"/>
+            <a:off x="5853393" y="1796693"/>
             <a:ext cx="5714192" cy="4397341"/>
           </a:xfrm>
           <a:prstGeom prst="rect">
@@ -4027,6 +3983,207 @@
           </a:prstGeom>
         </p:spPr>
       </p:pic>
+      <p:sp>
+        <p:nvSpPr>
+          <p:cNvPr id="8" name="DSPIRA 1"/>
+          <p:cNvSpPr>
+            <a:spLocks noGrp="1"/>
+          </p:cNvSpPr>
+          <p:nvPr/>
+        </p:nvSpPr>
+        <p:spPr>
+          <a:xfrm>
+            <a:off x="0" y="0"/>
+            <a:ext cx="12192000" cy="342900"/>
+          </a:xfrm>
+          <a:prstGeom prst="rect">
+            <a:avLst/>
+          </a:prstGeom>
+          <a:solidFill>
+            <a:srgbClr val="FFFFFF"/>
+          </a:solidFill>
+          <a:ln w="0">
+            <a:noFill/>
+          </a:ln>
+        </p:spPr>
+      </p:sp>
+      <p:sp>
+        <p:nvSpPr>
+          <p:cNvPr id="9" name="DSPIRA 2"/>
+          <p:cNvSpPr>
+            <a:spLocks noGrp="1"/>
+          </p:cNvSpPr>
+          <p:nvPr/>
+        </p:nvSpPr>
+        <p:spPr>
+          <a:xfrm>
+            <a:off x="0" y="7200900"/>
+            <a:ext cx="12192000" cy="342900"/>
+          </a:xfrm>
+          <a:prstGeom prst="rect">
+            <a:avLst/>
+          </a:prstGeom>
+          <a:solidFill>
+            <a:srgbClr val="FFFFFF"/>
+          </a:solidFill>
+          <a:ln w="0">
+            <a:noFill/>
+          </a:ln>
+        </p:spPr>
+      </p:sp>
+      <p:sp>
+        <p:nvSpPr>
+          <p:cNvPr id="10" name="DSPIRA 3"/>
+          <p:cNvSpPr>
+            <a:spLocks noGrp="1"/>
+          </p:cNvSpPr>
+          <p:nvPr/>
+        </p:nvSpPr>
+        <p:spPr>
+          <a:xfrm>
+            <a:off x="228600" y="76200"/>
+            <a:ext cx="4762500" cy="228600"/>
+          </a:xfrm>
+          <a:prstGeom prst="rect">
+            <a:avLst/>
+          </a:prstGeom>
+          <a:noFill/>
+          <a:ln w="0">
+            <a:noFill/>
+          </a:ln>
+        </p:spPr>
+        <p:txBody>
+          <a:bodyPr>
+            <a:noAutofit/>
+          </a:bodyPr>
+          <a:lstStyle/>
+          <a:p>
+            <a:pPr>
+              <a:defRPr sz="1200" b="1">
+                <a:solidFill>
+                  <a:srgbClr val="002855"/>
+                </a:solidFill>
+                <a:latin typeface="Arial"/>
+                <a:ea typeface="Arial"/>
+                <a:cs typeface="Arial"/>
+              </a:defRPr>
+            </a:pPr>
+            <a:r>
+              <a:rPr sz="1200" b="1">
+                <a:solidFill>
+                  <a:srgbClr val="002855"/>
+                </a:solidFill>
+                <a:latin typeface="Arial"/>
+                <a:ea typeface="Arial"/>
+                <a:cs typeface="Arial"/>
+              </a:rPr>
+              <a:t>WVU DSPIRA</a:t>
+            </a:r>
+          </a:p>
+        </p:txBody>
+      </p:sp>
+      <p:sp>
+        <p:nvSpPr>
+          <p:cNvPr id="11" name="DSPIRA 4"/>
+          <p:cNvSpPr>
+            <a:spLocks noGrp="1"/>
+          </p:cNvSpPr>
+          <p:nvPr/>
+        </p:nvSpPr>
+        <p:spPr>
+          <a:xfrm>
+            <a:off x="228600" y="7277100"/>
+            <a:ext cx="6667500" cy="228600"/>
+          </a:xfrm>
+          <a:prstGeom prst="rect">
+            <a:avLst/>
+          </a:prstGeom>
+          <a:noFill/>
+          <a:ln w="0">
+            <a:noFill/>
+          </a:ln>
+        </p:spPr>
+        <p:txBody>
+          <a:bodyPr>
+            <a:noAutofit/>
+          </a:bodyPr>
+          <a:lstStyle/>
+          <a:p>
+            <a:pPr>
+              <a:defRPr sz="900" b="0">
+                <a:solidFill>
+                  <a:srgbClr val="002855"/>
+                </a:solidFill>
+                <a:latin typeface="Arial"/>
+                <a:ea typeface="Arial"/>
+                <a:cs typeface="Arial"/>
+              </a:defRPr>
+            </a:pPr>
+            <a:r>
+              <a:rPr sz="900" b="0">
+                <a:solidFill>
+                  <a:srgbClr val="002855"/>
+                </a:solidFill>
+                <a:latin typeface="Arial"/>
+                <a:ea typeface="Arial"/>
+                <a:cs typeface="Arial"/>
+              </a:rPr>
+              <a:t>wvurail.org/dspira</a:t>
+            </a:r>
+          </a:p>
+        </p:txBody>
+      </p:sp>
+      <p:sp>
+        <p:nvSpPr>
+          <p:cNvPr id="12" name="DSPIRA 5"/>
+          <p:cNvSpPr>
+            <a:spLocks noGrp="1"/>
+          </p:cNvSpPr>
+          <p:nvPr/>
+        </p:nvSpPr>
+        <p:spPr>
+          <a:xfrm>
+            <a:off x="11191875" y="7277100"/>
+            <a:ext cx="762000" cy="228600"/>
+          </a:xfrm>
+          <a:prstGeom prst="rect">
+            <a:avLst/>
+          </a:prstGeom>
+          <a:noFill/>
+          <a:ln w="0">
+            <a:noFill/>
+          </a:ln>
+        </p:spPr>
+        <p:txBody>
+          <a:bodyPr>
+            <a:noAutofit/>
+          </a:bodyPr>
+          <a:lstStyle/>
+          <a:p>
+            <a:pPr>
+              <a:defRPr sz="900" b="0">
+                <a:solidFill>
+                  <a:srgbClr val="002855"/>
+                </a:solidFill>
+                <a:latin typeface="Arial"/>
+                <a:ea typeface="Arial"/>
+                <a:cs typeface="Arial"/>
+              </a:defRPr>
+            </a:pPr>
+            <a:r>
+              <a:rPr sz="900" b="0">
+                <a:solidFill>
+                  <a:srgbClr val="002855"/>
+                </a:solidFill>
+                <a:latin typeface="Arial"/>
+                <a:ea typeface="Arial"/>
+                <a:cs typeface="Arial"/>
+              </a:rPr>
+              <a:t>10 of 11</a:t>
+            </a:r>
+          </a:p>
+        </p:txBody>
+      </p:sp>
     </p:spTree>
     <p:extLst>
       <p:ext uri="{BB962C8B-B14F-4D97-AF65-F5344CB8AC3E}">
@@ -4113,35 +4270,6 @@
           </a:p>
         </p:txBody>
       </p:sp>
-      <p:sp>
-        <p:nvSpPr>
-          <p:cNvPr id="4" name="Slide Number Placeholder 3">
-            <a:extLst>
-              <a:ext uri="{FF2B5EF4-FFF2-40B4-BE49-F238E27FC236}">
-                <a16:creationId xmlns:a16="http://schemas.microsoft.com/office/drawing/2014/main" id="{9E93F12A-40CA-4FB3-8C9A-C0D14CF73C70}"/>
-              </a:ext>
-            </a:extLst>
-          </p:cNvPr>
-          <p:cNvSpPr>
-            <a:spLocks noGrp="1"/>
-          </p:cNvSpPr>
-          <p:nvPr>
-            <p:ph type="sldNum" sz="quarter" idx="12"/>
-          </p:nvPr>
-        </p:nvSpPr>
-        <p:spPr/>
-        <p:txBody>
-          <a:bodyPr/>
-          <a:lstStyle/>
-          <a:p>
-            <a:fld id="{9B986996-2D1E-405B-9CF9-B8943C230E7D}" type="slidenum">
-              <a:rPr lang="en-US" smtClean="0"/>
-              <a:t>11</a:t>
-            </a:fld>
-            <a:endParaRPr lang="en-US"/>
-          </a:p>
-        </p:txBody>
-      </p:sp>
       <p:pic>
         <p:nvPicPr>
           <p:cNvPr id="6" name="Picture 5">
@@ -4170,7 +4298,7 @@
         </p:blipFill>
         <p:spPr>
           <a:xfrm>
-            <a:off x="736009" y="1505164"/>
+            <a:off x="736009" y="1848064"/>
             <a:ext cx="5782946" cy="4450250"/>
           </a:xfrm>
           <a:prstGeom prst="rect">
@@ -4192,7 +4320,7 @@
         </p:nvSpPr>
         <p:spPr>
           <a:xfrm>
-            <a:off x="7947061" y="2357919"/>
+            <a:off x="7947061" y="2700819"/>
             <a:ext cx="3317255" cy="461665"/>
           </a:xfrm>
           <a:prstGeom prst="rect">
@@ -4207,8 +4335,209 @@
           <a:lstStyle/>
           <a:p>
             <a:r>
-              <a:rPr lang="en-US" sz="2400" dirty="0"/>
+              <a:rPr lang="en-US" sz="1920" dirty="0"/>
               <a:t>Residual power = 0.0161 </a:t>
+            </a:r>
+          </a:p>
+        </p:txBody>
+      </p:sp>
+      <p:sp>
+        <p:nvSpPr>
+          <p:cNvPr id="8" name="DSPIRA 1"/>
+          <p:cNvSpPr>
+            <a:spLocks noGrp="1"/>
+          </p:cNvSpPr>
+          <p:nvPr/>
+        </p:nvSpPr>
+        <p:spPr>
+          <a:xfrm>
+            <a:off x="0" y="0"/>
+            <a:ext cx="12192000" cy="342900"/>
+          </a:xfrm>
+          <a:prstGeom prst="rect">
+            <a:avLst/>
+          </a:prstGeom>
+          <a:solidFill>
+            <a:srgbClr val="FFFFFF"/>
+          </a:solidFill>
+          <a:ln w="0">
+            <a:noFill/>
+          </a:ln>
+        </p:spPr>
+      </p:sp>
+      <p:sp>
+        <p:nvSpPr>
+          <p:cNvPr id="9" name="DSPIRA 2"/>
+          <p:cNvSpPr>
+            <a:spLocks noGrp="1"/>
+          </p:cNvSpPr>
+          <p:nvPr/>
+        </p:nvSpPr>
+        <p:spPr>
+          <a:xfrm>
+            <a:off x="0" y="7200900"/>
+            <a:ext cx="12192000" cy="342900"/>
+          </a:xfrm>
+          <a:prstGeom prst="rect">
+            <a:avLst/>
+          </a:prstGeom>
+          <a:solidFill>
+            <a:srgbClr val="FFFFFF"/>
+          </a:solidFill>
+          <a:ln w="0">
+            <a:noFill/>
+          </a:ln>
+        </p:spPr>
+      </p:sp>
+      <p:sp>
+        <p:nvSpPr>
+          <p:cNvPr id="10" name="DSPIRA 3"/>
+          <p:cNvSpPr>
+            <a:spLocks noGrp="1"/>
+          </p:cNvSpPr>
+          <p:nvPr/>
+        </p:nvSpPr>
+        <p:spPr>
+          <a:xfrm>
+            <a:off x="228600" y="76200"/>
+            <a:ext cx="4762500" cy="228600"/>
+          </a:xfrm>
+          <a:prstGeom prst="rect">
+            <a:avLst/>
+          </a:prstGeom>
+          <a:noFill/>
+          <a:ln w="0">
+            <a:noFill/>
+          </a:ln>
+        </p:spPr>
+        <p:txBody>
+          <a:bodyPr>
+            <a:noAutofit/>
+          </a:bodyPr>
+          <a:lstStyle/>
+          <a:p>
+            <a:pPr>
+              <a:defRPr sz="1200" b="1">
+                <a:solidFill>
+                  <a:srgbClr val="002855"/>
+                </a:solidFill>
+                <a:latin typeface="Arial"/>
+                <a:ea typeface="Arial"/>
+                <a:cs typeface="Arial"/>
+              </a:defRPr>
+            </a:pPr>
+            <a:r>
+              <a:rPr sz="1200" b="1">
+                <a:solidFill>
+                  <a:srgbClr val="002855"/>
+                </a:solidFill>
+                <a:latin typeface="Arial"/>
+                <a:ea typeface="Arial"/>
+                <a:cs typeface="Arial"/>
+              </a:rPr>
+              <a:t>WVU DSPIRA</a:t>
+            </a:r>
+          </a:p>
+        </p:txBody>
+      </p:sp>
+      <p:sp>
+        <p:nvSpPr>
+          <p:cNvPr id="11" name="DSPIRA 4"/>
+          <p:cNvSpPr>
+            <a:spLocks noGrp="1"/>
+          </p:cNvSpPr>
+          <p:nvPr/>
+        </p:nvSpPr>
+        <p:spPr>
+          <a:xfrm>
+            <a:off x="228600" y="7277100"/>
+            <a:ext cx="6667500" cy="228600"/>
+          </a:xfrm>
+          <a:prstGeom prst="rect">
+            <a:avLst/>
+          </a:prstGeom>
+          <a:noFill/>
+          <a:ln w="0">
+            <a:noFill/>
+          </a:ln>
+        </p:spPr>
+        <p:txBody>
+          <a:bodyPr>
+            <a:noAutofit/>
+          </a:bodyPr>
+          <a:lstStyle/>
+          <a:p>
+            <a:pPr>
+              <a:defRPr sz="900" b="0">
+                <a:solidFill>
+                  <a:srgbClr val="002855"/>
+                </a:solidFill>
+                <a:latin typeface="Arial"/>
+                <a:ea typeface="Arial"/>
+                <a:cs typeface="Arial"/>
+              </a:defRPr>
+            </a:pPr>
+            <a:r>
+              <a:rPr sz="900" b="0">
+                <a:solidFill>
+                  <a:srgbClr val="002855"/>
+                </a:solidFill>
+                <a:latin typeface="Arial"/>
+                <a:ea typeface="Arial"/>
+                <a:cs typeface="Arial"/>
+              </a:rPr>
+              <a:t>wvurail.org/dspira</a:t>
+            </a:r>
+          </a:p>
+        </p:txBody>
+      </p:sp>
+      <p:sp>
+        <p:nvSpPr>
+          <p:cNvPr id="12" name="DSPIRA 5"/>
+          <p:cNvSpPr>
+            <a:spLocks noGrp="1"/>
+          </p:cNvSpPr>
+          <p:nvPr/>
+        </p:nvSpPr>
+        <p:spPr>
+          <a:xfrm>
+            <a:off x="11191875" y="7277100"/>
+            <a:ext cx="762000" cy="228600"/>
+          </a:xfrm>
+          <a:prstGeom prst="rect">
+            <a:avLst/>
+          </a:prstGeom>
+          <a:noFill/>
+          <a:ln w="0">
+            <a:noFill/>
+          </a:ln>
+        </p:spPr>
+        <p:txBody>
+          <a:bodyPr>
+            <a:noAutofit/>
+          </a:bodyPr>
+          <a:lstStyle/>
+          <a:p>
+            <a:pPr>
+              <a:defRPr sz="900" b="0">
+                <a:solidFill>
+                  <a:srgbClr val="002855"/>
+                </a:solidFill>
+                <a:latin typeface="Arial"/>
+                <a:ea typeface="Arial"/>
+                <a:cs typeface="Arial"/>
+              </a:defRPr>
+            </a:pPr>
+            <a:r>
+              <a:rPr sz="900" b="0">
+                <a:solidFill>
+                  <a:srgbClr val="002855"/>
+                </a:solidFill>
+                <a:latin typeface="Arial"/>
+                <a:ea typeface="Arial"/>
+                <a:cs typeface="Arial"/>
+              </a:rPr>
+              <a:t>11 of 11</a:t>
             </a:r>
           </a:p>
         </p:txBody>
@@ -4261,7 +4590,7 @@
         </p:nvSpPr>
         <p:spPr>
           <a:xfrm>
-            <a:off x="838200" y="365125"/>
+            <a:off x="838200" y="708025"/>
             <a:ext cx="10515600" cy="872911"/>
           </a:xfrm>
         </p:spPr>
@@ -4301,35 +4630,6 @@
               <a:rPr lang="en-US"/>
               <a:t>February 2, 2018</a:t>
             </a:r>
-          </a:p>
-        </p:txBody>
-      </p:sp>
-      <p:sp>
-        <p:nvSpPr>
-          <p:cNvPr id="4" name="Slide Number Placeholder 3">
-            <a:extLst>
-              <a:ext uri="{FF2B5EF4-FFF2-40B4-BE49-F238E27FC236}">
-                <a16:creationId xmlns:a16="http://schemas.microsoft.com/office/drawing/2014/main" id="{4E78E383-895F-4767-92EC-1A6F63B12D3E}"/>
-              </a:ext>
-            </a:extLst>
-          </p:cNvPr>
-          <p:cNvSpPr>
-            <a:spLocks noGrp="1"/>
-          </p:cNvSpPr>
-          <p:nvPr>
-            <p:ph type="sldNum" sz="quarter" idx="12"/>
-          </p:nvPr>
-        </p:nvSpPr>
-        <p:spPr/>
-        <p:txBody>
-          <a:bodyPr/>
-          <a:lstStyle/>
-          <a:p>
-            <a:fld id="{9B986996-2D1E-405B-9CF9-B8943C230E7D}" type="slidenum">
-              <a:rPr lang="en-US" smtClean="0"/>
-              <a:t>2</a:t>
-            </a:fld>
-            <a:endParaRPr lang="en-US"/>
           </a:p>
         </p:txBody>
       </p:sp>
@@ -4361,7 +4661,7 @@
         </p:blipFill>
         <p:spPr>
           <a:xfrm>
-            <a:off x="325040" y="1453793"/>
+            <a:off x="325040" y="1796693"/>
             <a:ext cx="5577463" cy="4292122"/>
           </a:xfrm>
           <a:prstGeom prst="rect">
@@ -4397,7 +4697,7 @@
         </p:blipFill>
         <p:spPr>
           <a:xfrm>
-            <a:off x="6232903" y="1406321"/>
+            <a:off x="6232903" y="1749221"/>
             <a:ext cx="5700839" cy="4387065"/>
           </a:xfrm>
           <a:prstGeom prst="rect">
@@ -4405,6 +4705,207 @@
           </a:prstGeom>
         </p:spPr>
       </p:pic>
+      <p:sp>
+        <p:nvSpPr>
+          <p:cNvPr id="9" name="DSPIRA 1"/>
+          <p:cNvSpPr>
+            <a:spLocks noGrp="1"/>
+          </p:cNvSpPr>
+          <p:nvPr/>
+        </p:nvSpPr>
+        <p:spPr>
+          <a:xfrm>
+            <a:off x="0" y="0"/>
+            <a:ext cx="12192000" cy="342900"/>
+          </a:xfrm>
+          <a:prstGeom prst="rect">
+            <a:avLst/>
+          </a:prstGeom>
+          <a:solidFill>
+            <a:srgbClr val="FFFFFF"/>
+          </a:solidFill>
+          <a:ln w="0">
+            <a:noFill/>
+          </a:ln>
+        </p:spPr>
+      </p:sp>
+      <p:sp>
+        <p:nvSpPr>
+          <p:cNvPr id="10" name="DSPIRA 2"/>
+          <p:cNvSpPr>
+            <a:spLocks noGrp="1"/>
+          </p:cNvSpPr>
+          <p:nvPr/>
+        </p:nvSpPr>
+        <p:spPr>
+          <a:xfrm>
+            <a:off x="0" y="7200900"/>
+            <a:ext cx="12192000" cy="342900"/>
+          </a:xfrm>
+          <a:prstGeom prst="rect">
+            <a:avLst/>
+          </a:prstGeom>
+          <a:solidFill>
+            <a:srgbClr val="FFFFFF"/>
+          </a:solidFill>
+          <a:ln w="0">
+            <a:noFill/>
+          </a:ln>
+        </p:spPr>
+      </p:sp>
+      <p:sp>
+        <p:nvSpPr>
+          <p:cNvPr id="11" name="DSPIRA 3"/>
+          <p:cNvSpPr>
+            <a:spLocks noGrp="1"/>
+          </p:cNvSpPr>
+          <p:nvPr/>
+        </p:nvSpPr>
+        <p:spPr>
+          <a:xfrm>
+            <a:off x="228600" y="76200"/>
+            <a:ext cx="4762500" cy="228600"/>
+          </a:xfrm>
+          <a:prstGeom prst="rect">
+            <a:avLst/>
+          </a:prstGeom>
+          <a:noFill/>
+          <a:ln w="0">
+            <a:noFill/>
+          </a:ln>
+        </p:spPr>
+        <p:txBody>
+          <a:bodyPr>
+            <a:noAutofit/>
+          </a:bodyPr>
+          <a:lstStyle/>
+          <a:p>
+            <a:pPr>
+              <a:defRPr sz="1200" b="1">
+                <a:solidFill>
+                  <a:srgbClr val="002855"/>
+                </a:solidFill>
+                <a:latin typeface="Arial"/>
+                <a:ea typeface="Arial"/>
+                <a:cs typeface="Arial"/>
+              </a:defRPr>
+            </a:pPr>
+            <a:r>
+              <a:rPr sz="1200" b="1">
+                <a:solidFill>
+                  <a:srgbClr val="002855"/>
+                </a:solidFill>
+                <a:latin typeface="Arial"/>
+                <a:ea typeface="Arial"/>
+                <a:cs typeface="Arial"/>
+              </a:rPr>
+              <a:t>WVU DSPIRA</a:t>
+            </a:r>
+          </a:p>
+        </p:txBody>
+      </p:sp>
+      <p:sp>
+        <p:nvSpPr>
+          <p:cNvPr id="12" name="DSPIRA 4"/>
+          <p:cNvSpPr>
+            <a:spLocks noGrp="1"/>
+          </p:cNvSpPr>
+          <p:nvPr/>
+        </p:nvSpPr>
+        <p:spPr>
+          <a:xfrm>
+            <a:off x="228600" y="7277100"/>
+            <a:ext cx="6667500" cy="228600"/>
+          </a:xfrm>
+          <a:prstGeom prst="rect">
+            <a:avLst/>
+          </a:prstGeom>
+          <a:noFill/>
+          <a:ln w="0">
+            <a:noFill/>
+          </a:ln>
+        </p:spPr>
+        <p:txBody>
+          <a:bodyPr>
+            <a:noAutofit/>
+          </a:bodyPr>
+          <a:lstStyle/>
+          <a:p>
+            <a:pPr>
+              <a:defRPr sz="900" b="0">
+                <a:solidFill>
+                  <a:srgbClr val="002855"/>
+                </a:solidFill>
+                <a:latin typeface="Arial"/>
+                <a:ea typeface="Arial"/>
+                <a:cs typeface="Arial"/>
+              </a:defRPr>
+            </a:pPr>
+            <a:r>
+              <a:rPr sz="900" b="0">
+                <a:solidFill>
+                  <a:srgbClr val="002855"/>
+                </a:solidFill>
+                <a:latin typeface="Arial"/>
+                <a:ea typeface="Arial"/>
+                <a:cs typeface="Arial"/>
+              </a:rPr>
+              <a:t>wvurail.org/dspira</a:t>
+            </a:r>
+          </a:p>
+        </p:txBody>
+      </p:sp>
+      <p:sp>
+        <p:nvSpPr>
+          <p:cNvPr id="13" name="DSPIRA 5"/>
+          <p:cNvSpPr>
+            <a:spLocks noGrp="1"/>
+          </p:cNvSpPr>
+          <p:nvPr/>
+        </p:nvSpPr>
+        <p:spPr>
+          <a:xfrm>
+            <a:off x="11191875" y="7277100"/>
+            <a:ext cx="762000" cy="228600"/>
+          </a:xfrm>
+          <a:prstGeom prst="rect">
+            <a:avLst/>
+          </a:prstGeom>
+          <a:noFill/>
+          <a:ln w="0">
+            <a:noFill/>
+          </a:ln>
+        </p:spPr>
+        <p:txBody>
+          <a:bodyPr>
+            <a:noAutofit/>
+          </a:bodyPr>
+          <a:lstStyle/>
+          <a:p>
+            <a:pPr>
+              <a:defRPr sz="900" b="0">
+                <a:solidFill>
+                  <a:srgbClr val="002855"/>
+                </a:solidFill>
+                <a:latin typeface="Arial"/>
+                <a:ea typeface="Arial"/>
+                <a:cs typeface="Arial"/>
+              </a:defRPr>
+            </a:pPr>
+            <a:r>
+              <a:rPr sz="900" b="0">
+                <a:solidFill>
+                  <a:srgbClr val="002855"/>
+                </a:solidFill>
+                <a:latin typeface="Arial"/>
+                <a:ea typeface="Arial"/>
+                <a:cs typeface="Arial"/>
+              </a:rPr>
+              <a:t>2 of 11</a:t>
+            </a:r>
+          </a:p>
+        </p:txBody>
+      </p:sp>
     </p:spTree>
     <p:extLst>
       <p:ext uri="{BB962C8B-B14F-4D97-AF65-F5344CB8AC3E}">
@@ -4453,7 +4954,7 @@
         </p:nvSpPr>
         <p:spPr>
           <a:xfrm>
-            <a:off x="838200" y="365126"/>
+            <a:off x="838200" y="708026"/>
             <a:ext cx="10515600" cy="1011612"/>
           </a:xfrm>
         </p:spPr>
@@ -4493,35 +4994,6 @@
               <a:rPr lang="en-US"/>
               <a:t>February 2, 2018</a:t>
             </a:r>
-          </a:p>
-        </p:txBody>
-      </p:sp>
-      <p:sp>
-        <p:nvSpPr>
-          <p:cNvPr id="4" name="Slide Number Placeholder 3">
-            <a:extLst>
-              <a:ext uri="{FF2B5EF4-FFF2-40B4-BE49-F238E27FC236}">
-                <a16:creationId xmlns:a16="http://schemas.microsoft.com/office/drawing/2014/main" id="{D8EABDB8-0E47-4756-8DF3-B9D8DDBD4C86}"/>
-              </a:ext>
-            </a:extLst>
-          </p:cNvPr>
-          <p:cNvSpPr>
-            <a:spLocks noGrp="1"/>
-          </p:cNvSpPr>
-          <p:nvPr>
-            <p:ph type="sldNum" sz="quarter" idx="12"/>
-          </p:nvPr>
-        </p:nvSpPr>
-        <p:spPr/>
-        <p:txBody>
-          <a:bodyPr/>
-          <a:lstStyle/>
-          <a:p>
-            <a:fld id="{9B986996-2D1E-405B-9CF9-B8943C230E7D}" type="slidenum">
-              <a:rPr lang="en-US" smtClean="0"/>
-              <a:t>3</a:t>
-            </a:fld>
-            <a:endParaRPr lang="en-US"/>
           </a:p>
         </p:txBody>
       </p:sp>
@@ -4553,7 +5025,7 @@
         </p:blipFill>
         <p:spPr>
           <a:xfrm>
-            <a:off x="1213757" y="1433245"/>
+            <a:off x="1213757" y="1776145"/>
             <a:ext cx="5839454" cy="4493736"/>
           </a:xfrm>
           <a:prstGeom prst="rect">
@@ -4575,7 +5047,7 @@
         </p:nvSpPr>
         <p:spPr>
           <a:xfrm>
-            <a:off x="7947061" y="2357919"/>
+            <a:off x="7947061" y="2700819"/>
             <a:ext cx="3248325" cy="830997"/>
           </a:xfrm>
           <a:prstGeom prst="rect">
@@ -4591,15 +5063,216 @@
           <a:p>
             <a:pPr algn="r"/>
             <a:r>
-              <a:rPr lang="en-US" sz="2400" dirty="0"/>
+              <a:rPr lang="en-US" sz="1920" dirty="0"/>
               <a:t>Residual power = 0.1964</a:t>
             </a:r>
           </a:p>
           <a:p>
             <a:pPr algn="r"/>
             <a:r>
-              <a:rPr lang="en-US" sz="2400" dirty="0"/>
+              <a:rPr lang="en-US" sz="1920" dirty="0"/>
               <a:t>(Watts) </a:t>
+            </a:r>
+          </a:p>
+        </p:txBody>
+      </p:sp>
+      <p:sp>
+        <p:nvSpPr>
+          <p:cNvPr id="8" name="DSPIRA 1"/>
+          <p:cNvSpPr>
+            <a:spLocks noGrp="1"/>
+          </p:cNvSpPr>
+          <p:nvPr/>
+        </p:nvSpPr>
+        <p:spPr>
+          <a:xfrm>
+            <a:off x="0" y="0"/>
+            <a:ext cx="12192000" cy="342900"/>
+          </a:xfrm>
+          <a:prstGeom prst="rect">
+            <a:avLst/>
+          </a:prstGeom>
+          <a:solidFill>
+            <a:srgbClr val="FFFFFF"/>
+          </a:solidFill>
+          <a:ln w="0">
+            <a:noFill/>
+          </a:ln>
+        </p:spPr>
+      </p:sp>
+      <p:sp>
+        <p:nvSpPr>
+          <p:cNvPr id="9" name="DSPIRA 2"/>
+          <p:cNvSpPr>
+            <a:spLocks noGrp="1"/>
+          </p:cNvSpPr>
+          <p:nvPr/>
+        </p:nvSpPr>
+        <p:spPr>
+          <a:xfrm>
+            <a:off x="0" y="7200900"/>
+            <a:ext cx="12192000" cy="342900"/>
+          </a:xfrm>
+          <a:prstGeom prst="rect">
+            <a:avLst/>
+          </a:prstGeom>
+          <a:solidFill>
+            <a:srgbClr val="FFFFFF"/>
+          </a:solidFill>
+          <a:ln w="0">
+            <a:noFill/>
+          </a:ln>
+        </p:spPr>
+      </p:sp>
+      <p:sp>
+        <p:nvSpPr>
+          <p:cNvPr id="10" name="DSPIRA 3"/>
+          <p:cNvSpPr>
+            <a:spLocks noGrp="1"/>
+          </p:cNvSpPr>
+          <p:nvPr/>
+        </p:nvSpPr>
+        <p:spPr>
+          <a:xfrm>
+            <a:off x="228600" y="76200"/>
+            <a:ext cx="4762500" cy="228600"/>
+          </a:xfrm>
+          <a:prstGeom prst="rect">
+            <a:avLst/>
+          </a:prstGeom>
+          <a:noFill/>
+          <a:ln w="0">
+            <a:noFill/>
+          </a:ln>
+        </p:spPr>
+        <p:txBody>
+          <a:bodyPr>
+            <a:noAutofit/>
+          </a:bodyPr>
+          <a:lstStyle/>
+          <a:p>
+            <a:pPr>
+              <a:defRPr sz="1200" b="1">
+                <a:solidFill>
+                  <a:srgbClr val="002855"/>
+                </a:solidFill>
+                <a:latin typeface="Arial"/>
+                <a:ea typeface="Arial"/>
+                <a:cs typeface="Arial"/>
+              </a:defRPr>
+            </a:pPr>
+            <a:r>
+              <a:rPr sz="1200" b="1">
+                <a:solidFill>
+                  <a:srgbClr val="002855"/>
+                </a:solidFill>
+                <a:latin typeface="Arial"/>
+                <a:ea typeface="Arial"/>
+                <a:cs typeface="Arial"/>
+              </a:rPr>
+              <a:t>WVU DSPIRA</a:t>
+            </a:r>
+          </a:p>
+        </p:txBody>
+      </p:sp>
+      <p:sp>
+        <p:nvSpPr>
+          <p:cNvPr id="11" name="DSPIRA 4"/>
+          <p:cNvSpPr>
+            <a:spLocks noGrp="1"/>
+          </p:cNvSpPr>
+          <p:nvPr/>
+        </p:nvSpPr>
+        <p:spPr>
+          <a:xfrm>
+            <a:off x="228600" y="7277100"/>
+            <a:ext cx="6667500" cy="228600"/>
+          </a:xfrm>
+          <a:prstGeom prst="rect">
+            <a:avLst/>
+          </a:prstGeom>
+          <a:noFill/>
+          <a:ln w="0">
+            <a:noFill/>
+          </a:ln>
+        </p:spPr>
+        <p:txBody>
+          <a:bodyPr>
+            <a:noAutofit/>
+          </a:bodyPr>
+          <a:lstStyle/>
+          <a:p>
+            <a:pPr>
+              <a:defRPr sz="900" b="0">
+                <a:solidFill>
+                  <a:srgbClr val="002855"/>
+                </a:solidFill>
+                <a:latin typeface="Arial"/>
+                <a:ea typeface="Arial"/>
+                <a:cs typeface="Arial"/>
+              </a:defRPr>
+            </a:pPr>
+            <a:r>
+              <a:rPr sz="900" b="0">
+                <a:solidFill>
+                  <a:srgbClr val="002855"/>
+                </a:solidFill>
+                <a:latin typeface="Arial"/>
+                <a:ea typeface="Arial"/>
+                <a:cs typeface="Arial"/>
+              </a:rPr>
+              <a:t>wvurail.org/dspira</a:t>
+            </a:r>
+          </a:p>
+        </p:txBody>
+      </p:sp>
+      <p:sp>
+        <p:nvSpPr>
+          <p:cNvPr id="12" name="DSPIRA 5"/>
+          <p:cNvSpPr>
+            <a:spLocks noGrp="1"/>
+          </p:cNvSpPr>
+          <p:nvPr/>
+        </p:nvSpPr>
+        <p:spPr>
+          <a:xfrm>
+            <a:off x="11191875" y="7277100"/>
+            <a:ext cx="762000" cy="228600"/>
+          </a:xfrm>
+          <a:prstGeom prst="rect">
+            <a:avLst/>
+          </a:prstGeom>
+          <a:noFill/>
+          <a:ln w="0">
+            <a:noFill/>
+          </a:ln>
+        </p:spPr>
+        <p:txBody>
+          <a:bodyPr>
+            <a:noAutofit/>
+          </a:bodyPr>
+          <a:lstStyle/>
+          <a:p>
+            <a:pPr>
+              <a:defRPr sz="900" b="0">
+                <a:solidFill>
+                  <a:srgbClr val="002855"/>
+                </a:solidFill>
+                <a:latin typeface="Arial"/>
+                <a:ea typeface="Arial"/>
+                <a:cs typeface="Arial"/>
+              </a:defRPr>
+            </a:pPr>
+            <a:r>
+              <a:rPr sz="900" b="0">
+                <a:solidFill>
+                  <a:srgbClr val="002855"/>
+                </a:solidFill>
+                <a:latin typeface="Arial"/>
+                <a:ea typeface="Arial"/>
+                <a:cs typeface="Arial"/>
+              </a:rPr>
+              <a:t>3 of 11</a:t>
             </a:r>
           </a:p>
         </p:txBody>
@@ -4652,7 +5325,7 @@
         </p:nvSpPr>
         <p:spPr>
           <a:xfrm>
-            <a:off x="838200" y="365125"/>
+            <a:off x="838200" y="708025"/>
             <a:ext cx="10515600" cy="970515"/>
           </a:xfrm>
         </p:spPr>
@@ -4692,35 +5365,6 @@
               <a:rPr lang="en-US"/>
               <a:t>February 2, 2018</a:t>
             </a:r>
-          </a:p>
-        </p:txBody>
-      </p:sp>
-      <p:sp>
-        <p:nvSpPr>
-          <p:cNvPr id="4" name="Slide Number Placeholder 3">
-            <a:extLst>
-              <a:ext uri="{FF2B5EF4-FFF2-40B4-BE49-F238E27FC236}">
-                <a16:creationId xmlns:a16="http://schemas.microsoft.com/office/drawing/2014/main" id="{70DA67A6-4791-4F83-BBC9-B737B5D978E4}"/>
-              </a:ext>
-            </a:extLst>
-          </p:cNvPr>
-          <p:cNvSpPr>
-            <a:spLocks noGrp="1"/>
-          </p:cNvSpPr>
-          <p:nvPr>
-            <p:ph type="sldNum" sz="quarter" idx="12"/>
-          </p:nvPr>
-        </p:nvSpPr>
-        <p:spPr/>
-        <p:txBody>
-          <a:bodyPr/>
-          <a:lstStyle/>
-          <a:p>
-            <a:fld id="{9B986996-2D1E-405B-9CF9-B8943C230E7D}" type="slidenum">
-              <a:rPr lang="en-US" smtClean="0"/>
-              <a:t>4</a:t>
-            </a:fld>
-            <a:endParaRPr lang="en-US"/>
           </a:p>
         </p:txBody>
       </p:sp>
@@ -4752,7 +5396,7 @@
         </p:blipFill>
         <p:spPr>
           <a:xfrm>
-            <a:off x="325040" y="1453793"/>
+            <a:off x="325040" y="1796693"/>
             <a:ext cx="5577463" cy="4292122"/>
           </a:xfrm>
           <a:prstGeom prst="rect">
@@ -4788,7 +5432,7 @@
         </p:blipFill>
         <p:spPr>
           <a:xfrm>
-            <a:off x="6289499" y="1453793"/>
+            <a:off x="6289499" y="1796693"/>
             <a:ext cx="5647435" cy="4345969"/>
           </a:xfrm>
           <a:prstGeom prst="rect">
@@ -4796,6 +5440,207 @@
           </a:prstGeom>
         </p:spPr>
       </p:pic>
+      <p:sp>
+        <p:nvSpPr>
+          <p:cNvPr id="8" name="DSPIRA 1"/>
+          <p:cNvSpPr>
+            <a:spLocks noGrp="1"/>
+          </p:cNvSpPr>
+          <p:nvPr/>
+        </p:nvSpPr>
+        <p:spPr>
+          <a:xfrm>
+            <a:off x="0" y="0"/>
+            <a:ext cx="12192000" cy="342900"/>
+          </a:xfrm>
+          <a:prstGeom prst="rect">
+            <a:avLst/>
+          </a:prstGeom>
+          <a:solidFill>
+            <a:srgbClr val="FFFFFF"/>
+          </a:solidFill>
+          <a:ln w="0">
+            <a:noFill/>
+          </a:ln>
+        </p:spPr>
+      </p:sp>
+      <p:sp>
+        <p:nvSpPr>
+          <p:cNvPr id="9" name="DSPIRA 2"/>
+          <p:cNvSpPr>
+            <a:spLocks noGrp="1"/>
+          </p:cNvSpPr>
+          <p:nvPr/>
+        </p:nvSpPr>
+        <p:spPr>
+          <a:xfrm>
+            <a:off x="0" y="7200900"/>
+            <a:ext cx="12192000" cy="342900"/>
+          </a:xfrm>
+          <a:prstGeom prst="rect">
+            <a:avLst/>
+          </a:prstGeom>
+          <a:solidFill>
+            <a:srgbClr val="FFFFFF"/>
+          </a:solidFill>
+          <a:ln w="0">
+            <a:noFill/>
+          </a:ln>
+        </p:spPr>
+      </p:sp>
+      <p:sp>
+        <p:nvSpPr>
+          <p:cNvPr id="10" name="DSPIRA 3"/>
+          <p:cNvSpPr>
+            <a:spLocks noGrp="1"/>
+          </p:cNvSpPr>
+          <p:nvPr/>
+        </p:nvSpPr>
+        <p:spPr>
+          <a:xfrm>
+            <a:off x="228600" y="76200"/>
+            <a:ext cx="4762500" cy="228600"/>
+          </a:xfrm>
+          <a:prstGeom prst="rect">
+            <a:avLst/>
+          </a:prstGeom>
+          <a:noFill/>
+          <a:ln w="0">
+            <a:noFill/>
+          </a:ln>
+        </p:spPr>
+        <p:txBody>
+          <a:bodyPr>
+            <a:noAutofit/>
+          </a:bodyPr>
+          <a:lstStyle/>
+          <a:p>
+            <a:pPr>
+              <a:defRPr sz="1200" b="1">
+                <a:solidFill>
+                  <a:srgbClr val="002855"/>
+                </a:solidFill>
+                <a:latin typeface="Arial"/>
+                <a:ea typeface="Arial"/>
+                <a:cs typeface="Arial"/>
+              </a:defRPr>
+            </a:pPr>
+            <a:r>
+              <a:rPr sz="1200" b="1">
+                <a:solidFill>
+                  <a:srgbClr val="002855"/>
+                </a:solidFill>
+                <a:latin typeface="Arial"/>
+                <a:ea typeface="Arial"/>
+                <a:cs typeface="Arial"/>
+              </a:rPr>
+              <a:t>WVU DSPIRA</a:t>
+            </a:r>
+          </a:p>
+        </p:txBody>
+      </p:sp>
+      <p:sp>
+        <p:nvSpPr>
+          <p:cNvPr id="11" name="DSPIRA 4"/>
+          <p:cNvSpPr>
+            <a:spLocks noGrp="1"/>
+          </p:cNvSpPr>
+          <p:nvPr/>
+        </p:nvSpPr>
+        <p:spPr>
+          <a:xfrm>
+            <a:off x="228600" y="7277100"/>
+            <a:ext cx="6667500" cy="228600"/>
+          </a:xfrm>
+          <a:prstGeom prst="rect">
+            <a:avLst/>
+          </a:prstGeom>
+          <a:noFill/>
+          <a:ln w="0">
+            <a:noFill/>
+          </a:ln>
+        </p:spPr>
+        <p:txBody>
+          <a:bodyPr>
+            <a:noAutofit/>
+          </a:bodyPr>
+          <a:lstStyle/>
+          <a:p>
+            <a:pPr>
+              <a:defRPr sz="900" b="0">
+                <a:solidFill>
+                  <a:srgbClr val="002855"/>
+                </a:solidFill>
+                <a:latin typeface="Arial"/>
+                <a:ea typeface="Arial"/>
+                <a:cs typeface="Arial"/>
+              </a:defRPr>
+            </a:pPr>
+            <a:r>
+              <a:rPr sz="900" b="0">
+                <a:solidFill>
+                  <a:srgbClr val="002855"/>
+                </a:solidFill>
+                <a:latin typeface="Arial"/>
+                <a:ea typeface="Arial"/>
+                <a:cs typeface="Arial"/>
+              </a:rPr>
+              <a:t>wvurail.org/dspira</a:t>
+            </a:r>
+          </a:p>
+        </p:txBody>
+      </p:sp>
+      <p:sp>
+        <p:nvSpPr>
+          <p:cNvPr id="12" name="DSPIRA 5"/>
+          <p:cNvSpPr>
+            <a:spLocks noGrp="1"/>
+          </p:cNvSpPr>
+          <p:nvPr/>
+        </p:nvSpPr>
+        <p:spPr>
+          <a:xfrm>
+            <a:off x="11191875" y="7277100"/>
+            <a:ext cx="762000" cy="228600"/>
+          </a:xfrm>
+          <a:prstGeom prst="rect">
+            <a:avLst/>
+          </a:prstGeom>
+          <a:noFill/>
+          <a:ln w="0">
+            <a:noFill/>
+          </a:ln>
+        </p:spPr>
+        <p:txBody>
+          <a:bodyPr>
+            <a:noAutofit/>
+          </a:bodyPr>
+          <a:lstStyle/>
+          <a:p>
+            <a:pPr>
+              <a:defRPr sz="900" b="0">
+                <a:solidFill>
+                  <a:srgbClr val="002855"/>
+                </a:solidFill>
+                <a:latin typeface="Arial"/>
+                <a:ea typeface="Arial"/>
+                <a:cs typeface="Arial"/>
+              </a:defRPr>
+            </a:pPr>
+            <a:r>
+              <a:rPr sz="900" b="0">
+                <a:solidFill>
+                  <a:srgbClr val="002855"/>
+                </a:solidFill>
+                <a:latin typeface="Arial"/>
+                <a:ea typeface="Arial"/>
+                <a:cs typeface="Arial"/>
+              </a:rPr>
+              <a:t>4 of 11</a:t>
+            </a:r>
+          </a:p>
+        </p:txBody>
+      </p:sp>
     </p:spTree>
     <p:extLst>
       <p:ext uri="{BB962C8B-B14F-4D97-AF65-F5344CB8AC3E}">
@@ -4882,35 +5727,6 @@
           </a:p>
         </p:txBody>
       </p:sp>
-      <p:sp>
-        <p:nvSpPr>
-          <p:cNvPr id="4" name="Slide Number Placeholder 3">
-            <a:extLst>
-              <a:ext uri="{FF2B5EF4-FFF2-40B4-BE49-F238E27FC236}">
-                <a16:creationId xmlns:a16="http://schemas.microsoft.com/office/drawing/2014/main" id="{534ADB41-7C3F-42AD-A661-33DB72A57BC0}"/>
-              </a:ext>
-            </a:extLst>
-          </p:cNvPr>
-          <p:cNvSpPr>
-            <a:spLocks noGrp="1"/>
-          </p:cNvSpPr>
-          <p:nvPr>
-            <p:ph type="sldNum" sz="quarter" idx="12"/>
-          </p:nvPr>
-        </p:nvSpPr>
-        <p:spPr/>
-        <p:txBody>
-          <a:bodyPr/>
-          <a:lstStyle/>
-          <a:p>
-            <a:fld id="{9B986996-2D1E-405B-9CF9-B8943C230E7D}" type="slidenum">
-              <a:rPr lang="en-US" smtClean="0"/>
-              <a:t>5</a:t>
-            </a:fld>
-            <a:endParaRPr lang="en-US"/>
-          </a:p>
-        </p:txBody>
-      </p:sp>
       <p:pic>
         <p:nvPicPr>
           <p:cNvPr id="6" name="Picture 5">
@@ -4939,7 +5755,7 @@
         </p:blipFill>
         <p:spPr>
           <a:xfrm>
-            <a:off x="982740" y="1592495"/>
+            <a:off x="982740" y="1935395"/>
             <a:ext cx="5633817" cy="4335488"/>
           </a:xfrm>
           <a:prstGeom prst="rect">
@@ -4961,7 +5777,7 @@
         </p:nvSpPr>
         <p:spPr>
           <a:xfrm>
-            <a:off x="7947061" y="2357919"/>
+            <a:off x="7947061" y="2700819"/>
             <a:ext cx="3317255" cy="461665"/>
           </a:xfrm>
           <a:prstGeom prst="rect">
@@ -4976,8 +5792,209 @@
           <a:lstStyle/>
           <a:p>
             <a:r>
-              <a:rPr lang="en-US" sz="2400" dirty="0"/>
+              <a:rPr lang="en-US" sz="1920" dirty="0"/>
               <a:t>Residual power = 0.1046 </a:t>
+            </a:r>
+          </a:p>
+        </p:txBody>
+      </p:sp>
+      <p:sp>
+        <p:nvSpPr>
+          <p:cNvPr id="8" name="DSPIRA 1"/>
+          <p:cNvSpPr>
+            <a:spLocks noGrp="1"/>
+          </p:cNvSpPr>
+          <p:nvPr/>
+        </p:nvSpPr>
+        <p:spPr>
+          <a:xfrm>
+            <a:off x="0" y="0"/>
+            <a:ext cx="12192000" cy="342900"/>
+          </a:xfrm>
+          <a:prstGeom prst="rect">
+            <a:avLst/>
+          </a:prstGeom>
+          <a:solidFill>
+            <a:srgbClr val="FFFFFF"/>
+          </a:solidFill>
+          <a:ln w="0">
+            <a:noFill/>
+          </a:ln>
+        </p:spPr>
+      </p:sp>
+      <p:sp>
+        <p:nvSpPr>
+          <p:cNvPr id="9" name="DSPIRA 2"/>
+          <p:cNvSpPr>
+            <a:spLocks noGrp="1"/>
+          </p:cNvSpPr>
+          <p:nvPr/>
+        </p:nvSpPr>
+        <p:spPr>
+          <a:xfrm>
+            <a:off x="0" y="7200900"/>
+            <a:ext cx="12192000" cy="342900"/>
+          </a:xfrm>
+          <a:prstGeom prst="rect">
+            <a:avLst/>
+          </a:prstGeom>
+          <a:solidFill>
+            <a:srgbClr val="FFFFFF"/>
+          </a:solidFill>
+          <a:ln w="0">
+            <a:noFill/>
+          </a:ln>
+        </p:spPr>
+      </p:sp>
+      <p:sp>
+        <p:nvSpPr>
+          <p:cNvPr id="10" name="DSPIRA 3"/>
+          <p:cNvSpPr>
+            <a:spLocks noGrp="1"/>
+          </p:cNvSpPr>
+          <p:nvPr/>
+        </p:nvSpPr>
+        <p:spPr>
+          <a:xfrm>
+            <a:off x="228600" y="76200"/>
+            <a:ext cx="4762500" cy="228600"/>
+          </a:xfrm>
+          <a:prstGeom prst="rect">
+            <a:avLst/>
+          </a:prstGeom>
+          <a:noFill/>
+          <a:ln w="0">
+            <a:noFill/>
+          </a:ln>
+        </p:spPr>
+        <p:txBody>
+          <a:bodyPr>
+            <a:noAutofit/>
+          </a:bodyPr>
+          <a:lstStyle/>
+          <a:p>
+            <a:pPr>
+              <a:defRPr sz="1200" b="1">
+                <a:solidFill>
+                  <a:srgbClr val="002855"/>
+                </a:solidFill>
+                <a:latin typeface="Arial"/>
+                <a:ea typeface="Arial"/>
+                <a:cs typeface="Arial"/>
+              </a:defRPr>
+            </a:pPr>
+            <a:r>
+              <a:rPr sz="1200" b="1">
+                <a:solidFill>
+                  <a:srgbClr val="002855"/>
+                </a:solidFill>
+                <a:latin typeface="Arial"/>
+                <a:ea typeface="Arial"/>
+                <a:cs typeface="Arial"/>
+              </a:rPr>
+              <a:t>WVU DSPIRA</a:t>
+            </a:r>
+          </a:p>
+        </p:txBody>
+      </p:sp>
+      <p:sp>
+        <p:nvSpPr>
+          <p:cNvPr id="11" name="DSPIRA 4"/>
+          <p:cNvSpPr>
+            <a:spLocks noGrp="1"/>
+          </p:cNvSpPr>
+          <p:nvPr/>
+        </p:nvSpPr>
+        <p:spPr>
+          <a:xfrm>
+            <a:off x="228600" y="7277100"/>
+            <a:ext cx="6667500" cy="228600"/>
+          </a:xfrm>
+          <a:prstGeom prst="rect">
+            <a:avLst/>
+          </a:prstGeom>
+          <a:noFill/>
+          <a:ln w="0">
+            <a:noFill/>
+          </a:ln>
+        </p:spPr>
+        <p:txBody>
+          <a:bodyPr>
+            <a:noAutofit/>
+          </a:bodyPr>
+          <a:lstStyle/>
+          <a:p>
+            <a:pPr>
+              <a:defRPr sz="900" b="0">
+                <a:solidFill>
+                  <a:srgbClr val="002855"/>
+                </a:solidFill>
+                <a:latin typeface="Arial"/>
+                <a:ea typeface="Arial"/>
+                <a:cs typeface="Arial"/>
+              </a:defRPr>
+            </a:pPr>
+            <a:r>
+              <a:rPr sz="900" b="0">
+                <a:solidFill>
+                  <a:srgbClr val="002855"/>
+                </a:solidFill>
+                <a:latin typeface="Arial"/>
+                <a:ea typeface="Arial"/>
+                <a:cs typeface="Arial"/>
+              </a:rPr>
+              <a:t>wvurail.org/dspira</a:t>
+            </a:r>
+          </a:p>
+        </p:txBody>
+      </p:sp>
+      <p:sp>
+        <p:nvSpPr>
+          <p:cNvPr id="12" name="DSPIRA 5"/>
+          <p:cNvSpPr>
+            <a:spLocks noGrp="1"/>
+          </p:cNvSpPr>
+          <p:nvPr/>
+        </p:nvSpPr>
+        <p:spPr>
+          <a:xfrm>
+            <a:off x="11191875" y="7277100"/>
+            <a:ext cx="762000" cy="228600"/>
+          </a:xfrm>
+          <a:prstGeom prst="rect">
+            <a:avLst/>
+          </a:prstGeom>
+          <a:noFill/>
+          <a:ln w="0">
+            <a:noFill/>
+          </a:ln>
+        </p:spPr>
+        <p:txBody>
+          <a:bodyPr>
+            <a:noAutofit/>
+          </a:bodyPr>
+          <a:lstStyle/>
+          <a:p>
+            <a:pPr>
+              <a:defRPr sz="900" b="0">
+                <a:solidFill>
+                  <a:srgbClr val="002855"/>
+                </a:solidFill>
+                <a:latin typeface="Arial"/>
+                <a:ea typeface="Arial"/>
+                <a:cs typeface="Arial"/>
+              </a:defRPr>
+            </a:pPr>
+            <a:r>
+              <a:rPr sz="900" b="0">
+                <a:solidFill>
+                  <a:srgbClr val="002855"/>
+                </a:solidFill>
+                <a:latin typeface="Arial"/>
+                <a:ea typeface="Arial"/>
+                <a:cs typeface="Arial"/>
+              </a:rPr>
+              <a:t>5 of 11</a:t>
             </a:r>
           </a:p>
         </p:txBody>
@@ -5030,7 +6047,7 @@
         </p:nvSpPr>
         <p:spPr>
           <a:xfrm>
-            <a:off x="838200" y="365125"/>
+            <a:off x="838200" y="708025"/>
             <a:ext cx="10515600" cy="1037297"/>
           </a:xfrm>
         </p:spPr>
@@ -5070,35 +6087,6 @@
               <a:rPr lang="en-US"/>
               <a:t>February 2, 2018</a:t>
             </a:r>
-          </a:p>
-        </p:txBody>
-      </p:sp>
-      <p:sp>
-        <p:nvSpPr>
-          <p:cNvPr id="4" name="Slide Number Placeholder 3">
-            <a:extLst>
-              <a:ext uri="{FF2B5EF4-FFF2-40B4-BE49-F238E27FC236}">
-                <a16:creationId xmlns:a16="http://schemas.microsoft.com/office/drawing/2014/main" id="{F248DE93-7F0B-416A-86C8-C6BA85B4D5ED}"/>
-              </a:ext>
-            </a:extLst>
-          </p:cNvPr>
-          <p:cNvSpPr>
-            <a:spLocks noGrp="1"/>
-          </p:cNvSpPr>
-          <p:nvPr>
-            <p:ph type="sldNum" sz="quarter" idx="12"/>
-          </p:nvPr>
-        </p:nvSpPr>
-        <p:spPr/>
-        <p:txBody>
-          <a:bodyPr/>
-          <a:lstStyle/>
-          <a:p>
-            <a:fld id="{9B986996-2D1E-405B-9CF9-B8943C230E7D}" type="slidenum">
-              <a:rPr lang="en-US" smtClean="0"/>
-              <a:t>6</a:t>
-            </a:fld>
-            <a:endParaRPr lang="en-US"/>
           </a:p>
         </p:txBody>
       </p:sp>
@@ -5130,7 +6118,7 @@
         </p:blipFill>
         <p:spPr>
           <a:xfrm>
-            <a:off x="325040" y="1453793"/>
+            <a:off x="325040" y="1796693"/>
             <a:ext cx="5577463" cy="4292122"/>
           </a:xfrm>
           <a:prstGeom prst="rect">
@@ -5166,7 +6154,7 @@
         </p:blipFill>
         <p:spPr>
           <a:xfrm>
-            <a:off x="5966409" y="1453793"/>
+            <a:off x="5966409" y="1796693"/>
             <a:ext cx="5814321" cy="4474396"/>
           </a:xfrm>
           <a:prstGeom prst="rect">
@@ -5174,6 +6162,207 @@
           </a:prstGeom>
         </p:spPr>
       </p:pic>
+      <p:sp>
+        <p:nvSpPr>
+          <p:cNvPr id="8" name="DSPIRA 1"/>
+          <p:cNvSpPr>
+            <a:spLocks noGrp="1"/>
+          </p:cNvSpPr>
+          <p:nvPr/>
+        </p:nvSpPr>
+        <p:spPr>
+          <a:xfrm>
+            <a:off x="0" y="0"/>
+            <a:ext cx="12192000" cy="342900"/>
+          </a:xfrm>
+          <a:prstGeom prst="rect">
+            <a:avLst/>
+          </a:prstGeom>
+          <a:solidFill>
+            <a:srgbClr val="FFFFFF"/>
+          </a:solidFill>
+          <a:ln w="0">
+            <a:noFill/>
+          </a:ln>
+        </p:spPr>
+      </p:sp>
+      <p:sp>
+        <p:nvSpPr>
+          <p:cNvPr id="9" name="DSPIRA 2"/>
+          <p:cNvSpPr>
+            <a:spLocks noGrp="1"/>
+          </p:cNvSpPr>
+          <p:nvPr/>
+        </p:nvSpPr>
+        <p:spPr>
+          <a:xfrm>
+            <a:off x="0" y="7200900"/>
+            <a:ext cx="12192000" cy="342900"/>
+          </a:xfrm>
+          <a:prstGeom prst="rect">
+            <a:avLst/>
+          </a:prstGeom>
+          <a:solidFill>
+            <a:srgbClr val="FFFFFF"/>
+          </a:solidFill>
+          <a:ln w="0">
+            <a:noFill/>
+          </a:ln>
+        </p:spPr>
+      </p:sp>
+      <p:sp>
+        <p:nvSpPr>
+          <p:cNvPr id="10" name="DSPIRA 3"/>
+          <p:cNvSpPr>
+            <a:spLocks noGrp="1"/>
+          </p:cNvSpPr>
+          <p:nvPr/>
+        </p:nvSpPr>
+        <p:spPr>
+          <a:xfrm>
+            <a:off x="228600" y="76200"/>
+            <a:ext cx="4762500" cy="228600"/>
+          </a:xfrm>
+          <a:prstGeom prst="rect">
+            <a:avLst/>
+          </a:prstGeom>
+          <a:noFill/>
+          <a:ln w="0">
+            <a:noFill/>
+          </a:ln>
+        </p:spPr>
+        <p:txBody>
+          <a:bodyPr>
+            <a:noAutofit/>
+          </a:bodyPr>
+          <a:lstStyle/>
+          <a:p>
+            <a:pPr>
+              <a:defRPr sz="1200" b="1">
+                <a:solidFill>
+                  <a:srgbClr val="002855"/>
+                </a:solidFill>
+                <a:latin typeface="Arial"/>
+                <a:ea typeface="Arial"/>
+                <a:cs typeface="Arial"/>
+              </a:defRPr>
+            </a:pPr>
+            <a:r>
+              <a:rPr sz="1200" b="1">
+                <a:solidFill>
+                  <a:srgbClr val="002855"/>
+                </a:solidFill>
+                <a:latin typeface="Arial"/>
+                <a:ea typeface="Arial"/>
+                <a:cs typeface="Arial"/>
+              </a:rPr>
+              <a:t>WVU DSPIRA</a:t>
+            </a:r>
+          </a:p>
+        </p:txBody>
+      </p:sp>
+      <p:sp>
+        <p:nvSpPr>
+          <p:cNvPr id="11" name="DSPIRA 4"/>
+          <p:cNvSpPr>
+            <a:spLocks noGrp="1"/>
+          </p:cNvSpPr>
+          <p:nvPr/>
+        </p:nvSpPr>
+        <p:spPr>
+          <a:xfrm>
+            <a:off x="228600" y="7277100"/>
+            <a:ext cx="6667500" cy="228600"/>
+          </a:xfrm>
+          <a:prstGeom prst="rect">
+            <a:avLst/>
+          </a:prstGeom>
+          <a:noFill/>
+          <a:ln w="0">
+            <a:noFill/>
+          </a:ln>
+        </p:spPr>
+        <p:txBody>
+          <a:bodyPr>
+            <a:noAutofit/>
+          </a:bodyPr>
+          <a:lstStyle/>
+          <a:p>
+            <a:pPr>
+              <a:defRPr sz="900" b="0">
+                <a:solidFill>
+                  <a:srgbClr val="002855"/>
+                </a:solidFill>
+                <a:latin typeface="Arial"/>
+                <a:ea typeface="Arial"/>
+                <a:cs typeface="Arial"/>
+              </a:defRPr>
+            </a:pPr>
+            <a:r>
+              <a:rPr sz="900" b="0">
+                <a:solidFill>
+                  <a:srgbClr val="002855"/>
+                </a:solidFill>
+                <a:latin typeface="Arial"/>
+                <a:ea typeface="Arial"/>
+                <a:cs typeface="Arial"/>
+              </a:rPr>
+              <a:t>wvurail.org/dspira</a:t>
+            </a:r>
+          </a:p>
+        </p:txBody>
+      </p:sp>
+      <p:sp>
+        <p:nvSpPr>
+          <p:cNvPr id="12" name="DSPIRA 5"/>
+          <p:cNvSpPr>
+            <a:spLocks noGrp="1"/>
+          </p:cNvSpPr>
+          <p:nvPr/>
+        </p:nvSpPr>
+        <p:spPr>
+          <a:xfrm>
+            <a:off x="11191875" y="7277100"/>
+            <a:ext cx="762000" cy="228600"/>
+          </a:xfrm>
+          <a:prstGeom prst="rect">
+            <a:avLst/>
+          </a:prstGeom>
+          <a:noFill/>
+          <a:ln w="0">
+            <a:noFill/>
+          </a:ln>
+        </p:spPr>
+        <p:txBody>
+          <a:bodyPr>
+            <a:noAutofit/>
+          </a:bodyPr>
+          <a:lstStyle/>
+          <a:p>
+            <a:pPr>
+              <a:defRPr sz="900" b="0">
+                <a:solidFill>
+                  <a:srgbClr val="002855"/>
+                </a:solidFill>
+                <a:latin typeface="Arial"/>
+                <a:ea typeface="Arial"/>
+                <a:cs typeface="Arial"/>
+              </a:defRPr>
+            </a:pPr>
+            <a:r>
+              <a:rPr sz="900" b="0">
+                <a:solidFill>
+                  <a:srgbClr val="002855"/>
+                </a:solidFill>
+                <a:latin typeface="Arial"/>
+                <a:ea typeface="Arial"/>
+                <a:cs typeface="Arial"/>
+              </a:rPr>
+              <a:t>6 of 11</a:t>
+            </a:r>
+          </a:p>
+        </p:txBody>
+      </p:sp>
     </p:spTree>
     <p:extLst>
       <p:ext uri="{BB962C8B-B14F-4D97-AF65-F5344CB8AC3E}">
@@ -5260,35 +6449,6 @@
           </a:p>
         </p:txBody>
       </p:sp>
-      <p:sp>
-        <p:nvSpPr>
-          <p:cNvPr id="4" name="Slide Number Placeholder 3">
-            <a:extLst>
-              <a:ext uri="{FF2B5EF4-FFF2-40B4-BE49-F238E27FC236}">
-                <a16:creationId xmlns:a16="http://schemas.microsoft.com/office/drawing/2014/main" id="{2AFECC42-BB47-4143-A83F-1AA56CA8BD54}"/>
-              </a:ext>
-            </a:extLst>
-          </p:cNvPr>
-          <p:cNvSpPr>
-            <a:spLocks noGrp="1"/>
-          </p:cNvSpPr>
-          <p:nvPr>
-            <p:ph type="sldNum" sz="quarter" idx="12"/>
-          </p:nvPr>
-        </p:nvSpPr>
-        <p:spPr/>
-        <p:txBody>
-          <a:bodyPr/>
-          <a:lstStyle/>
-          <a:p>
-            <a:fld id="{9B986996-2D1E-405B-9CF9-B8943C230E7D}" type="slidenum">
-              <a:rPr lang="en-US" smtClean="0"/>
-              <a:t>7</a:t>
-            </a:fld>
-            <a:endParaRPr lang="en-US"/>
-          </a:p>
-        </p:txBody>
-      </p:sp>
       <p:pic>
         <p:nvPicPr>
           <p:cNvPr id="6" name="Picture 5">
@@ -5317,7 +6477,7 @@
         </p:blipFill>
         <p:spPr>
           <a:xfrm>
-            <a:off x="838200" y="1577083"/>
+            <a:off x="838200" y="1919983"/>
             <a:ext cx="5860002" cy="4509549"/>
           </a:xfrm>
           <a:prstGeom prst="rect">
@@ -5339,7 +6499,7 @@
         </p:nvSpPr>
         <p:spPr>
           <a:xfrm>
-            <a:off x="7947061" y="2357919"/>
+            <a:off x="7947061" y="2700819"/>
             <a:ext cx="3317255" cy="461665"/>
           </a:xfrm>
           <a:prstGeom prst="rect">
@@ -5354,8 +6514,209 @@
           <a:lstStyle/>
           <a:p>
             <a:r>
-              <a:rPr lang="en-US" sz="2400" dirty="0"/>
+              <a:rPr lang="en-US" sz="1920" dirty="0"/>
               <a:t>Residual power = 0.0723 </a:t>
+            </a:r>
+          </a:p>
+        </p:txBody>
+      </p:sp>
+      <p:sp>
+        <p:nvSpPr>
+          <p:cNvPr id="8" name="DSPIRA 1"/>
+          <p:cNvSpPr>
+            <a:spLocks noGrp="1"/>
+          </p:cNvSpPr>
+          <p:nvPr/>
+        </p:nvSpPr>
+        <p:spPr>
+          <a:xfrm>
+            <a:off x="0" y="0"/>
+            <a:ext cx="12192000" cy="342900"/>
+          </a:xfrm>
+          <a:prstGeom prst="rect">
+            <a:avLst/>
+          </a:prstGeom>
+          <a:solidFill>
+            <a:srgbClr val="FFFFFF"/>
+          </a:solidFill>
+          <a:ln w="0">
+            <a:noFill/>
+          </a:ln>
+        </p:spPr>
+      </p:sp>
+      <p:sp>
+        <p:nvSpPr>
+          <p:cNvPr id="9" name="DSPIRA 2"/>
+          <p:cNvSpPr>
+            <a:spLocks noGrp="1"/>
+          </p:cNvSpPr>
+          <p:nvPr/>
+        </p:nvSpPr>
+        <p:spPr>
+          <a:xfrm>
+            <a:off x="0" y="7200900"/>
+            <a:ext cx="12192000" cy="342900"/>
+          </a:xfrm>
+          <a:prstGeom prst="rect">
+            <a:avLst/>
+          </a:prstGeom>
+          <a:solidFill>
+            <a:srgbClr val="FFFFFF"/>
+          </a:solidFill>
+          <a:ln w="0">
+            <a:noFill/>
+          </a:ln>
+        </p:spPr>
+      </p:sp>
+      <p:sp>
+        <p:nvSpPr>
+          <p:cNvPr id="10" name="DSPIRA 3"/>
+          <p:cNvSpPr>
+            <a:spLocks noGrp="1"/>
+          </p:cNvSpPr>
+          <p:nvPr/>
+        </p:nvSpPr>
+        <p:spPr>
+          <a:xfrm>
+            <a:off x="228600" y="76200"/>
+            <a:ext cx="4762500" cy="228600"/>
+          </a:xfrm>
+          <a:prstGeom prst="rect">
+            <a:avLst/>
+          </a:prstGeom>
+          <a:noFill/>
+          <a:ln w="0">
+            <a:noFill/>
+          </a:ln>
+        </p:spPr>
+        <p:txBody>
+          <a:bodyPr>
+            <a:noAutofit/>
+          </a:bodyPr>
+          <a:lstStyle/>
+          <a:p>
+            <a:pPr>
+              <a:defRPr sz="1200" b="1">
+                <a:solidFill>
+                  <a:srgbClr val="002855"/>
+                </a:solidFill>
+                <a:latin typeface="Arial"/>
+                <a:ea typeface="Arial"/>
+                <a:cs typeface="Arial"/>
+              </a:defRPr>
+            </a:pPr>
+            <a:r>
+              <a:rPr sz="1200" b="1">
+                <a:solidFill>
+                  <a:srgbClr val="002855"/>
+                </a:solidFill>
+                <a:latin typeface="Arial"/>
+                <a:ea typeface="Arial"/>
+                <a:cs typeface="Arial"/>
+              </a:rPr>
+              <a:t>WVU DSPIRA</a:t>
+            </a:r>
+          </a:p>
+        </p:txBody>
+      </p:sp>
+      <p:sp>
+        <p:nvSpPr>
+          <p:cNvPr id="11" name="DSPIRA 4"/>
+          <p:cNvSpPr>
+            <a:spLocks noGrp="1"/>
+          </p:cNvSpPr>
+          <p:nvPr/>
+        </p:nvSpPr>
+        <p:spPr>
+          <a:xfrm>
+            <a:off x="228600" y="7277100"/>
+            <a:ext cx="6667500" cy="228600"/>
+          </a:xfrm>
+          <a:prstGeom prst="rect">
+            <a:avLst/>
+          </a:prstGeom>
+          <a:noFill/>
+          <a:ln w="0">
+            <a:noFill/>
+          </a:ln>
+        </p:spPr>
+        <p:txBody>
+          <a:bodyPr>
+            <a:noAutofit/>
+          </a:bodyPr>
+          <a:lstStyle/>
+          <a:p>
+            <a:pPr>
+              <a:defRPr sz="900" b="0">
+                <a:solidFill>
+                  <a:srgbClr val="002855"/>
+                </a:solidFill>
+                <a:latin typeface="Arial"/>
+                <a:ea typeface="Arial"/>
+                <a:cs typeface="Arial"/>
+              </a:defRPr>
+            </a:pPr>
+            <a:r>
+              <a:rPr sz="900" b="0">
+                <a:solidFill>
+                  <a:srgbClr val="002855"/>
+                </a:solidFill>
+                <a:latin typeface="Arial"/>
+                <a:ea typeface="Arial"/>
+                <a:cs typeface="Arial"/>
+              </a:rPr>
+              <a:t>wvurail.org/dspira</a:t>
+            </a:r>
+          </a:p>
+        </p:txBody>
+      </p:sp>
+      <p:sp>
+        <p:nvSpPr>
+          <p:cNvPr id="12" name="DSPIRA 5"/>
+          <p:cNvSpPr>
+            <a:spLocks noGrp="1"/>
+          </p:cNvSpPr>
+          <p:nvPr/>
+        </p:nvSpPr>
+        <p:spPr>
+          <a:xfrm>
+            <a:off x="11191875" y="7277100"/>
+            <a:ext cx="762000" cy="228600"/>
+          </a:xfrm>
+          <a:prstGeom prst="rect">
+            <a:avLst/>
+          </a:prstGeom>
+          <a:noFill/>
+          <a:ln w="0">
+            <a:noFill/>
+          </a:ln>
+        </p:spPr>
+        <p:txBody>
+          <a:bodyPr>
+            <a:noAutofit/>
+          </a:bodyPr>
+          <a:lstStyle/>
+          <a:p>
+            <a:pPr>
+              <a:defRPr sz="900" b="0">
+                <a:solidFill>
+                  <a:srgbClr val="002855"/>
+                </a:solidFill>
+                <a:latin typeface="Arial"/>
+                <a:ea typeface="Arial"/>
+                <a:cs typeface="Arial"/>
+              </a:defRPr>
+            </a:pPr>
+            <a:r>
+              <a:rPr sz="900" b="0">
+                <a:solidFill>
+                  <a:srgbClr val="002855"/>
+                </a:solidFill>
+                <a:latin typeface="Arial"/>
+                <a:ea typeface="Arial"/>
+                <a:cs typeface="Arial"/>
+              </a:rPr>
+              <a:t>7 of 11</a:t>
             </a:r>
           </a:p>
         </p:txBody>
@@ -5408,7 +6769,7 @@
         </p:nvSpPr>
         <p:spPr>
           <a:xfrm>
-            <a:off x="838200" y="365126"/>
+            <a:off x="838200" y="708026"/>
             <a:ext cx="10515600" cy="1124628"/>
           </a:xfrm>
         </p:spPr>
@@ -5448,35 +6809,6 @@
               <a:rPr lang="en-US"/>
               <a:t>February 2, 2018</a:t>
             </a:r>
-          </a:p>
-        </p:txBody>
-      </p:sp>
-      <p:sp>
-        <p:nvSpPr>
-          <p:cNvPr id="4" name="Slide Number Placeholder 3">
-            <a:extLst>
-              <a:ext uri="{FF2B5EF4-FFF2-40B4-BE49-F238E27FC236}">
-                <a16:creationId xmlns:a16="http://schemas.microsoft.com/office/drawing/2014/main" id="{C44DAF38-FD7D-4282-BF2B-F973328BB242}"/>
-              </a:ext>
-            </a:extLst>
-          </p:cNvPr>
-          <p:cNvSpPr>
-            <a:spLocks noGrp="1"/>
-          </p:cNvSpPr>
-          <p:nvPr>
-            <p:ph type="sldNum" sz="quarter" idx="12"/>
-          </p:nvPr>
-        </p:nvSpPr>
-        <p:spPr/>
-        <p:txBody>
-          <a:bodyPr/>
-          <a:lstStyle/>
-          <a:p>
-            <a:fld id="{9B986996-2D1E-405B-9CF9-B8943C230E7D}" type="slidenum">
-              <a:rPr lang="en-US" smtClean="0"/>
-              <a:t>8</a:t>
-            </a:fld>
-            <a:endParaRPr lang="en-US"/>
           </a:p>
         </p:txBody>
       </p:sp>
@@ -5508,7 +6840,7 @@
         </p:blipFill>
         <p:spPr>
           <a:xfrm>
-            <a:off x="325040" y="1453793"/>
+            <a:off x="325040" y="1796693"/>
             <a:ext cx="5577463" cy="4292122"/>
           </a:xfrm>
           <a:prstGeom prst="rect">
@@ -5544,7 +6876,7 @@
         </p:blipFill>
         <p:spPr>
           <a:xfrm>
-            <a:off x="5965554" y="1419164"/>
+            <a:off x="5965554" y="1762064"/>
             <a:ext cx="5799242" cy="4462791"/>
           </a:xfrm>
           <a:prstGeom prst="rect">
@@ -5552,6 +6884,207 @@
           </a:prstGeom>
         </p:spPr>
       </p:pic>
+      <p:sp>
+        <p:nvSpPr>
+          <p:cNvPr id="14" name="DSPIRA 1"/>
+          <p:cNvSpPr>
+            <a:spLocks noGrp="1"/>
+          </p:cNvSpPr>
+          <p:nvPr/>
+        </p:nvSpPr>
+        <p:spPr>
+          <a:xfrm>
+            <a:off x="0" y="0"/>
+            <a:ext cx="12192000" cy="342900"/>
+          </a:xfrm>
+          <a:prstGeom prst="rect">
+            <a:avLst/>
+          </a:prstGeom>
+          <a:solidFill>
+            <a:srgbClr val="FFFFFF"/>
+          </a:solidFill>
+          <a:ln w="0">
+            <a:noFill/>
+          </a:ln>
+        </p:spPr>
+      </p:sp>
+      <p:sp>
+        <p:nvSpPr>
+          <p:cNvPr id="15" name="DSPIRA 2"/>
+          <p:cNvSpPr>
+            <a:spLocks noGrp="1"/>
+          </p:cNvSpPr>
+          <p:nvPr/>
+        </p:nvSpPr>
+        <p:spPr>
+          <a:xfrm>
+            <a:off x="0" y="7200900"/>
+            <a:ext cx="12192000" cy="342900"/>
+          </a:xfrm>
+          <a:prstGeom prst="rect">
+            <a:avLst/>
+          </a:prstGeom>
+          <a:solidFill>
+            <a:srgbClr val="FFFFFF"/>
+          </a:solidFill>
+          <a:ln w="0">
+            <a:noFill/>
+          </a:ln>
+        </p:spPr>
+      </p:sp>
+      <p:sp>
+        <p:nvSpPr>
+          <p:cNvPr id="16" name="DSPIRA 3"/>
+          <p:cNvSpPr>
+            <a:spLocks noGrp="1"/>
+          </p:cNvSpPr>
+          <p:nvPr/>
+        </p:nvSpPr>
+        <p:spPr>
+          <a:xfrm>
+            <a:off x="228600" y="76200"/>
+            <a:ext cx="4762500" cy="228600"/>
+          </a:xfrm>
+          <a:prstGeom prst="rect">
+            <a:avLst/>
+          </a:prstGeom>
+          <a:noFill/>
+          <a:ln w="0">
+            <a:noFill/>
+          </a:ln>
+        </p:spPr>
+        <p:txBody>
+          <a:bodyPr>
+            <a:noAutofit/>
+          </a:bodyPr>
+          <a:lstStyle/>
+          <a:p>
+            <a:pPr>
+              <a:defRPr sz="1200" b="1">
+                <a:solidFill>
+                  <a:srgbClr val="002855"/>
+                </a:solidFill>
+                <a:latin typeface="Arial"/>
+                <a:ea typeface="Arial"/>
+                <a:cs typeface="Arial"/>
+              </a:defRPr>
+            </a:pPr>
+            <a:r>
+              <a:rPr sz="1200" b="1">
+                <a:solidFill>
+                  <a:srgbClr val="002855"/>
+                </a:solidFill>
+                <a:latin typeface="Arial"/>
+                <a:ea typeface="Arial"/>
+                <a:cs typeface="Arial"/>
+              </a:rPr>
+              <a:t>WVU DSPIRA</a:t>
+            </a:r>
+          </a:p>
+        </p:txBody>
+      </p:sp>
+      <p:sp>
+        <p:nvSpPr>
+          <p:cNvPr id="17" name="DSPIRA 4"/>
+          <p:cNvSpPr>
+            <a:spLocks noGrp="1"/>
+          </p:cNvSpPr>
+          <p:nvPr/>
+        </p:nvSpPr>
+        <p:spPr>
+          <a:xfrm>
+            <a:off x="228600" y="7277100"/>
+            <a:ext cx="6667500" cy="228600"/>
+          </a:xfrm>
+          <a:prstGeom prst="rect">
+            <a:avLst/>
+          </a:prstGeom>
+          <a:noFill/>
+          <a:ln w="0">
+            <a:noFill/>
+          </a:ln>
+        </p:spPr>
+        <p:txBody>
+          <a:bodyPr>
+            <a:noAutofit/>
+          </a:bodyPr>
+          <a:lstStyle/>
+          <a:p>
+            <a:pPr>
+              <a:defRPr sz="900" b="0">
+                <a:solidFill>
+                  <a:srgbClr val="002855"/>
+                </a:solidFill>
+                <a:latin typeface="Arial"/>
+                <a:ea typeface="Arial"/>
+                <a:cs typeface="Arial"/>
+              </a:defRPr>
+            </a:pPr>
+            <a:r>
+              <a:rPr sz="900" b="0">
+                <a:solidFill>
+                  <a:srgbClr val="002855"/>
+                </a:solidFill>
+                <a:latin typeface="Arial"/>
+                <a:ea typeface="Arial"/>
+                <a:cs typeface="Arial"/>
+              </a:rPr>
+              <a:t>wvurail.org/dspira</a:t>
+            </a:r>
+          </a:p>
+        </p:txBody>
+      </p:sp>
+      <p:sp>
+        <p:nvSpPr>
+          <p:cNvPr id="18" name="DSPIRA 5"/>
+          <p:cNvSpPr>
+            <a:spLocks noGrp="1"/>
+          </p:cNvSpPr>
+          <p:nvPr/>
+        </p:nvSpPr>
+        <p:spPr>
+          <a:xfrm>
+            <a:off x="11191875" y="7277100"/>
+            <a:ext cx="762000" cy="228600"/>
+          </a:xfrm>
+          <a:prstGeom prst="rect">
+            <a:avLst/>
+          </a:prstGeom>
+          <a:noFill/>
+          <a:ln w="0">
+            <a:noFill/>
+          </a:ln>
+        </p:spPr>
+        <p:txBody>
+          <a:bodyPr>
+            <a:noAutofit/>
+          </a:bodyPr>
+          <a:lstStyle/>
+          <a:p>
+            <a:pPr>
+              <a:defRPr sz="900" b="0">
+                <a:solidFill>
+                  <a:srgbClr val="002855"/>
+                </a:solidFill>
+                <a:latin typeface="Arial"/>
+                <a:ea typeface="Arial"/>
+                <a:cs typeface="Arial"/>
+              </a:defRPr>
+            </a:pPr>
+            <a:r>
+              <a:rPr sz="900" b="0">
+                <a:solidFill>
+                  <a:srgbClr val="002855"/>
+                </a:solidFill>
+                <a:latin typeface="Arial"/>
+                <a:ea typeface="Arial"/>
+                <a:cs typeface="Arial"/>
+              </a:rPr>
+              <a:t>8 of 11</a:t>
+            </a:r>
+          </a:p>
+        </p:txBody>
+      </p:sp>
     </p:spTree>
     <p:extLst>
       <p:ext uri="{BB962C8B-B14F-4D97-AF65-F5344CB8AC3E}">
@@ -5638,35 +7171,6 @@
           </a:p>
         </p:txBody>
       </p:sp>
-      <p:sp>
-        <p:nvSpPr>
-          <p:cNvPr id="4" name="Slide Number Placeholder 3">
-            <a:extLst>
-              <a:ext uri="{FF2B5EF4-FFF2-40B4-BE49-F238E27FC236}">
-                <a16:creationId xmlns:a16="http://schemas.microsoft.com/office/drawing/2014/main" id="{17400640-4139-40F6-8461-5F79E5B4F116}"/>
-              </a:ext>
-            </a:extLst>
-          </p:cNvPr>
-          <p:cNvSpPr>
-            <a:spLocks noGrp="1"/>
-          </p:cNvSpPr>
-          <p:nvPr>
-            <p:ph type="sldNum" sz="quarter" idx="12"/>
-          </p:nvPr>
-        </p:nvSpPr>
-        <p:spPr/>
-        <p:txBody>
-          <a:bodyPr/>
-          <a:lstStyle/>
-          <a:p>
-            <a:fld id="{9B986996-2D1E-405B-9CF9-B8943C230E7D}" type="slidenum">
-              <a:rPr lang="en-US" smtClean="0"/>
-              <a:t>9</a:t>
-            </a:fld>
-            <a:endParaRPr lang="en-US"/>
-          </a:p>
-        </p:txBody>
-      </p:sp>
       <p:pic>
         <p:nvPicPr>
           <p:cNvPr id="6" name="Picture 5">
@@ -5695,7 +7199,7 @@
         </p:blipFill>
         <p:spPr>
           <a:xfrm>
-            <a:off x="1188070" y="1556535"/>
+            <a:off x="1188070" y="1899435"/>
             <a:ext cx="5531229" cy="4256542"/>
           </a:xfrm>
           <a:prstGeom prst="rect">
@@ -5717,7 +7221,7 @@
         </p:nvSpPr>
         <p:spPr>
           <a:xfrm>
-            <a:off x="7947061" y="2357919"/>
+            <a:off x="7947061" y="2700819"/>
             <a:ext cx="3317255" cy="461665"/>
           </a:xfrm>
           <a:prstGeom prst="rect">
@@ -5732,8 +7236,209 @@
           <a:lstStyle/>
           <a:p>
             <a:r>
-              <a:rPr lang="en-US" sz="2400" dirty="0"/>
+              <a:rPr lang="en-US" sz="1920" dirty="0"/>
               <a:t>Residual power = 0.031 4</a:t>
+            </a:r>
+          </a:p>
+        </p:txBody>
+      </p:sp>
+      <p:sp>
+        <p:nvSpPr>
+          <p:cNvPr id="8" name="DSPIRA 1"/>
+          <p:cNvSpPr>
+            <a:spLocks noGrp="1"/>
+          </p:cNvSpPr>
+          <p:nvPr/>
+        </p:nvSpPr>
+        <p:spPr>
+          <a:xfrm>
+            <a:off x="0" y="0"/>
+            <a:ext cx="12192000" cy="342900"/>
+          </a:xfrm>
+          <a:prstGeom prst="rect">
+            <a:avLst/>
+          </a:prstGeom>
+          <a:solidFill>
+            <a:srgbClr val="FFFFFF"/>
+          </a:solidFill>
+          <a:ln w="0">
+            <a:noFill/>
+          </a:ln>
+        </p:spPr>
+      </p:sp>
+      <p:sp>
+        <p:nvSpPr>
+          <p:cNvPr id="9" name="DSPIRA 2"/>
+          <p:cNvSpPr>
+            <a:spLocks noGrp="1"/>
+          </p:cNvSpPr>
+          <p:nvPr/>
+        </p:nvSpPr>
+        <p:spPr>
+          <a:xfrm>
+            <a:off x="0" y="7200900"/>
+            <a:ext cx="12192000" cy="342900"/>
+          </a:xfrm>
+          <a:prstGeom prst="rect">
+            <a:avLst/>
+          </a:prstGeom>
+          <a:solidFill>
+            <a:srgbClr val="FFFFFF"/>
+          </a:solidFill>
+          <a:ln w="0">
+            <a:noFill/>
+          </a:ln>
+        </p:spPr>
+      </p:sp>
+      <p:sp>
+        <p:nvSpPr>
+          <p:cNvPr id="10" name="DSPIRA 3"/>
+          <p:cNvSpPr>
+            <a:spLocks noGrp="1"/>
+          </p:cNvSpPr>
+          <p:nvPr/>
+        </p:nvSpPr>
+        <p:spPr>
+          <a:xfrm>
+            <a:off x="228600" y="76200"/>
+            <a:ext cx="4762500" cy="228600"/>
+          </a:xfrm>
+          <a:prstGeom prst="rect">
+            <a:avLst/>
+          </a:prstGeom>
+          <a:noFill/>
+          <a:ln w="0">
+            <a:noFill/>
+          </a:ln>
+        </p:spPr>
+        <p:txBody>
+          <a:bodyPr>
+            <a:noAutofit/>
+          </a:bodyPr>
+          <a:lstStyle/>
+          <a:p>
+            <a:pPr>
+              <a:defRPr sz="1200" b="1">
+                <a:solidFill>
+                  <a:srgbClr val="002855"/>
+                </a:solidFill>
+                <a:latin typeface="Arial"/>
+                <a:ea typeface="Arial"/>
+                <a:cs typeface="Arial"/>
+              </a:defRPr>
+            </a:pPr>
+            <a:r>
+              <a:rPr sz="1200" b="1">
+                <a:solidFill>
+                  <a:srgbClr val="002855"/>
+                </a:solidFill>
+                <a:latin typeface="Arial"/>
+                <a:ea typeface="Arial"/>
+                <a:cs typeface="Arial"/>
+              </a:rPr>
+              <a:t>WVU DSPIRA</a:t>
+            </a:r>
+          </a:p>
+        </p:txBody>
+      </p:sp>
+      <p:sp>
+        <p:nvSpPr>
+          <p:cNvPr id="11" name="DSPIRA 4"/>
+          <p:cNvSpPr>
+            <a:spLocks noGrp="1"/>
+          </p:cNvSpPr>
+          <p:nvPr/>
+        </p:nvSpPr>
+        <p:spPr>
+          <a:xfrm>
+            <a:off x="228600" y="7277100"/>
+            <a:ext cx="6667500" cy="228600"/>
+          </a:xfrm>
+          <a:prstGeom prst="rect">
+            <a:avLst/>
+          </a:prstGeom>
+          <a:noFill/>
+          <a:ln w="0">
+            <a:noFill/>
+          </a:ln>
+        </p:spPr>
+        <p:txBody>
+          <a:bodyPr>
+            <a:noAutofit/>
+          </a:bodyPr>
+          <a:lstStyle/>
+          <a:p>
+            <a:pPr>
+              <a:defRPr sz="900" b="0">
+                <a:solidFill>
+                  <a:srgbClr val="002855"/>
+                </a:solidFill>
+                <a:latin typeface="Arial"/>
+                <a:ea typeface="Arial"/>
+                <a:cs typeface="Arial"/>
+              </a:defRPr>
+            </a:pPr>
+            <a:r>
+              <a:rPr sz="900" b="0">
+                <a:solidFill>
+                  <a:srgbClr val="002855"/>
+                </a:solidFill>
+                <a:latin typeface="Arial"/>
+                <a:ea typeface="Arial"/>
+                <a:cs typeface="Arial"/>
+              </a:rPr>
+              <a:t>wvurail.org/dspira</a:t>
+            </a:r>
+          </a:p>
+        </p:txBody>
+      </p:sp>
+      <p:sp>
+        <p:nvSpPr>
+          <p:cNvPr id="12" name="DSPIRA 5"/>
+          <p:cNvSpPr>
+            <a:spLocks noGrp="1"/>
+          </p:cNvSpPr>
+          <p:nvPr/>
+        </p:nvSpPr>
+        <p:spPr>
+          <a:xfrm>
+            <a:off x="11191875" y="7277100"/>
+            <a:ext cx="762000" cy="228600"/>
+          </a:xfrm>
+          <a:prstGeom prst="rect">
+            <a:avLst/>
+          </a:prstGeom>
+          <a:noFill/>
+          <a:ln w="0">
+            <a:noFill/>
+          </a:ln>
+        </p:spPr>
+        <p:txBody>
+          <a:bodyPr>
+            <a:noAutofit/>
+          </a:bodyPr>
+          <a:lstStyle/>
+          <a:p>
+            <a:pPr>
+              <a:defRPr sz="900" b="0">
+                <a:solidFill>
+                  <a:srgbClr val="002855"/>
+                </a:solidFill>
+                <a:latin typeface="Arial"/>
+                <a:ea typeface="Arial"/>
+                <a:cs typeface="Arial"/>
+              </a:defRPr>
+            </a:pPr>
+            <a:r>
+              <a:rPr sz="900" b="0">
+                <a:solidFill>
+                  <a:srgbClr val="002855"/>
+                </a:solidFill>
+                <a:latin typeface="Arial"/>
+                <a:ea typeface="Arial"/>
+                <a:cs typeface="Arial"/>
+              </a:rPr>
+              <a:t>9 of 11</a:t>
             </a:r>
           </a:p>
         </p:txBody>
@@ -5794,7 +7499,7 @@
     </a:clrScheme>
     <a:fontScheme name="Office">
       <a:majorFont>
-        <a:latin typeface="Calibri Light" panose="020F0302020204030204"/>
+        <a:latin typeface="Arial" panose="020F0302020204030204"/>
         <a:ea typeface=""/>
         <a:cs typeface=""/>
         <a:font script="Jpan" typeface="游ゴシック Light"/>
@@ -5846,7 +7551,7 @@
         <a:font script="Tfng" typeface="Ebrima"/>
       </a:majorFont>
       <a:minorFont>
-        <a:latin typeface="Calibri" panose="020F0502020204030204"/>
+        <a:latin typeface="Arial" panose="020F0502020204030204"/>
         <a:ea typeface=""/>
         <a:cs typeface=""/>
         <a:font script="Jpan" typeface="游ゴシック"/>
@@ -6089,7 +7794,7 @@
     </a:clrScheme>
     <a:fontScheme name="Office">
       <a:majorFont>
-        <a:latin typeface="Calibri Light" panose="020F0302020204030204"/>
+        <a:latin typeface="Arial" panose="020F0302020204030204"/>
         <a:ea typeface=""/>
         <a:cs typeface=""/>
         <a:font script="Jpan" typeface="游ゴシック Light"/>
@@ -6141,7 +7846,7 @@
         <a:font script="Tfng" typeface="Ebrima"/>
       </a:majorFont>
       <a:minorFont>
-        <a:latin typeface="Calibri" panose="020F0502020204030204"/>
+        <a:latin typeface="Arial" panose="020F0502020204030204"/>
         <a:ea typeface=""/>
         <a:cs typeface=""/>
         <a:font script="Jpan" typeface="游ゴシック"/>
@@ -6339,183 +8044,4 @@
     </a:ext>
   </a:extLst>
 </a:theme>
-</file>
-
-<file path=customXml/item1.xml><?xml version="1.0" encoding="utf-8"?>
-<ct:contentTypeSchema xmlns:ct="http://schemas.microsoft.com/office/2006/metadata/contentType" xmlns:ma="http://schemas.microsoft.com/office/2006/metadata/properties/metaAttributes" ct:_="" ma:_="" ma:contentTypeName="Document" ma:contentTypeID="0x01010016C36F108F9F92488C988DDF36346911" ma:contentTypeVersion="5" ma:contentTypeDescription="Create a new document." ma:contentTypeScope="" ma:versionID="c417924321fef32731141cd966ef6f94">
-  <xsd:schema xmlns:xsd="http://www.w3.org/2001/XMLSchema" xmlns:xs="http://www.w3.org/2001/XMLSchema" xmlns:p="http://schemas.microsoft.com/office/2006/metadata/properties" xmlns:ns2="1bb24863-89de-455f-aabf-4424925aa312" targetNamespace="http://schemas.microsoft.com/office/2006/metadata/properties" ma:root="true" ma:fieldsID="a7d3b2212d350eb904df17fc79fef4f4" ns2:_="">
-    <xsd:import namespace="1bb24863-89de-455f-aabf-4424925aa312"/>
-    <xsd:element name="properties">
-      <xsd:complexType>
-        <xsd:sequence>
-          <xsd:element name="documentManagement">
-            <xsd:complexType>
-              <xsd:all>
-                <xsd:element ref="ns2:MediaServiceMetadata" minOccurs="0"/>
-                <xsd:element ref="ns2:MediaServiceFastMetadata" minOccurs="0"/>
-                <xsd:element ref="ns2:MediaServiceAutoTags" minOccurs="0"/>
-                <xsd:element ref="ns2:MediaServiceOCR" minOccurs="0"/>
-                <xsd:element ref="ns2:MediaServiceDateTaken" minOccurs="0"/>
-              </xsd:all>
-            </xsd:complexType>
-          </xsd:element>
-        </xsd:sequence>
-      </xsd:complexType>
-    </xsd:element>
-  </xsd:schema>
-  <xsd:schema xmlns:xsd="http://www.w3.org/2001/XMLSchema" xmlns:xs="http://www.w3.org/2001/XMLSchema" xmlns:dms="http://schemas.microsoft.com/office/2006/documentManagement/types" xmlns:pc="http://schemas.microsoft.com/office/infopath/2007/PartnerControls" targetNamespace="1bb24863-89de-455f-aabf-4424925aa312" elementFormDefault="qualified">
-    <xsd:import namespace="http://schemas.microsoft.com/office/2006/documentManagement/types"/>
-    <xsd:import namespace="http://schemas.microsoft.com/office/infopath/2007/PartnerControls"/>
-    <xsd:element name="MediaServiceMetadata" ma:index="8" nillable="true" ma:displayName="MediaServiceMetadata" ma:hidden="true" ma:internalName="MediaServiceMetadata" ma:readOnly="true">
-      <xsd:simpleType>
-        <xsd:restriction base="dms:Note"/>
-      </xsd:simpleType>
-    </xsd:element>
-    <xsd:element name="MediaServiceFastMetadata" ma:index="9" nillable="true" ma:displayName="MediaServiceFastMetadata" ma:hidden="true" ma:internalName="MediaServiceFastMetadata" ma:readOnly="true">
-      <xsd:simpleType>
-        <xsd:restriction base="dms:Note"/>
-      </xsd:simpleType>
-    </xsd:element>
-    <xsd:element name="MediaServiceAutoTags" ma:index="10" nillable="true" ma:displayName="MediaServiceAutoTags" ma:internalName="MediaServiceAutoTags" ma:readOnly="true">
-      <xsd:simpleType>
-        <xsd:restriction base="dms:Text"/>
-      </xsd:simpleType>
-    </xsd:element>
-    <xsd:element name="MediaServiceOCR" ma:index="11" nillable="true" ma:displayName="MediaServiceOCR" ma:internalName="MediaServiceOCR" ma:readOnly="true">
-      <xsd:simpleType>
-        <xsd:restriction base="dms:Note">
-          <xsd:maxLength value="255"/>
-        </xsd:restriction>
-      </xsd:simpleType>
-    </xsd:element>
-    <xsd:element name="MediaServiceDateTaken" ma:index="12" nillable="true" ma:displayName="MediaServiceDateTaken" ma:hidden="true" ma:internalName="MediaServiceDateTaken" ma:readOnly="true">
-      <xsd:simpleType>
-        <xsd:restriction base="dms:Text"/>
-      </xsd:simpleType>
-    </xsd:element>
-  </xsd:schema>
-  <xsd:schema xmlns="http://schemas.openxmlformats.org/package/2006/metadata/core-properties" xmlns:xsd="http://www.w3.org/2001/XMLSchema" xmlns:xsi="http://www.w3.org/2001/XMLSchema-instance" xmlns:dc="http://purl.org/dc/elements/1.1/" xmlns:dcterms="http://purl.org/dc/terms/" xmlns:odoc="http://schemas.microsoft.com/internal/obd" targetNamespace="http://schemas.openxmlformats.org/package/2006/metadata/core-properties" elementFormDefault="qualified" attributeFormDefault="unqualified" blockDefault="#all">
-    <xsd:import namespace="http://purl.org/dc/elements/1.1/" schemaLocation="http://dublincore.org/schemas/xmls/qdc/2003/04/02/dc.xsd"/>
-    <xsd:import namespace="http://purl.org/dc/terms/" schemaLocation="http://dublincore.org/schemas/xmls/qdc/2003/04/02/dcterms.xsd"/>
-    <xsd:element name="coreProperties" type="CT_coreProperties"/>
-    <xsd:complexType name="CT_coreProperties">
-      <xsd:all>
-        <xsd:element ref="dc:creator" minOccurs="0" maxOccurs="1"/>
-        <xsd:element ref="dcterms:created" minOccurs="0" maxOccurs="1"/>
-        <xsd:element ref="dc:identifier" minOccurs="0" maxOccurs="1"/>
-        <xsd:element name="contentType" minOccurs="0" maxOccurs="1" type="xsd:string" ma:index="0" ma:displayName="Content Type"/>
-        <xsd:element ref="dc:title" minOccurs="0" maxOccurs="1" ma:index="4" ma:displayName="Title"/>
-        <xsd:element ref="dc:subject" minOccurs="0" maxOccurs="1"/>
-        <xsd:element ref="dc:description" minOccurs="0" maxOccurs="1"/>
-        <xsd:element name="keywords" minOccurs="0" maxOccurs="1" type="xsd:string"/>
-        <xsd:element ref="dc:language" minOccurs="0" maxOccurs="1"/>
-        <xsd:element name="category" minOccurs="0" maxOccurs="1" type="xsd:string"/>
-        <xsd:element name="version" minOccurs="0" maxOccurs="1" type="xsd:string"/>
-        <xsd:element name="revision" minOccurs="0" maxOccurs="1" type="xsd:string">
-          <xsd:annotation>
-            <xsd:documentation>
-                        This value indicates the number of saves or revisions. The application is responsible for updating this value after each revision.
-                    </xsd:documentation>
-          </xsd:annotation>
-        </xsd:element>
-        <xsd:element name="lastModifiedBy" minOccurs="0" maxOccurs="1" type="xsd:string"/>
-        <xsd:element ref="dcterms:modified" minOccurs="0" maxOccurs="1"/>
-        <xsd:element name="contentStatus" minOccurs="0" maxOccurs="1" type="xsd:string"/>
-      </xsd:all>
-    </xsd:complexType>
-  </xsd:schema>
-  <xs:schema xmlns:pc="http://schemas.microsoft.com/office/infopath/2007/PartnerControls" xmlns:xs="http://www.w3.org/2001/XMLSchema" targetNamespace="http://schemas.microsoft.com/office/infopath/2007/PartnerControls" elementFormDefault="qualified" attributeFormDefault="unqualified">
-    <xs:element name="Person">
-      <xs:complexType>
-        <xs:sequence>
-          <xs:element ref="pc:DisplayName" minOccurs="0"/>
-          <xs:element ref="pc:AccountId" minOccurs="0"/>
-          <xs:element ref="pc:AccountType" minOccurs="0"/>
-        </xs:sequence>
-      </xs:complexType>
-    </xs:element>
-    <xs:element name="DisplayName" type="xs:string"/>
-    <xs:element name="AccountId" type="xs:string"/>
-    <xs:element name="AccountType" type="xs:string"/>
-    <xs:element name="BDCAssociatedEntity">
-      <xs:complexType>
-        <xs:sequence>
-          <xs:element ref="pc:BDCEntity" minOccurs="0" maxOccurs="unbounded"/>
-        </xs:sequence>
-        <xs:attribute ref="pc:EntityNamespace"/>
-        <xs:attribute ref="pc:EntityName"/>
-        <xs:attribute ref="pc:SystemInstanceName"/>
-        <xs:attribute ref="pc:AssociationName"/>
-      </xs:complexType>
-    </xs:element>
-    <xs:attribute name="EntityNamespace" type="xs:string"/>
-    <xs:attribute name="EntityName" type="xs:string"/>
-    <xs:attribute name="SystemInstanceName" type="xs:string"/>
-    <xs:attribute name="AssociationName" type="xs:string"/>
-    <xs:element name="BDCEntity">
-      <xs:complexType>
-        <xs:sequence>
-          <xs:element ref="pc:EntityDisplayName" minOccurs="0"/>
-          <xs:element ref="pc:EntityInstanceReference" minOccurs="0"/>
-          <xs:element ref="pc:EntityId1" minOccurs="0"/>
-          <xs:element ref="pc:EntityId2" minOccurs="0"/>
-          <xs:element ref="pc:EntityId3" minOccurs="0"/>
-          <xs:element ref="pc:EntityId4" minOccurs="0"/>
-          <xs:element ref="pc:EntityId5" minOccurs="0"/>
-        </xs:sequence>
-      </xs:complexType>
-    </xs:element>
-    <xs:element name="EntityDisplayName" type="xs:string"/>
-    <xs:element name="EntityInstanceReference" type="xs:string"/>
-    <xs:element name="EntityId1" type="xs:string"/>
-    <xs:element name="EntityId2" type="xs:string"/>
-    <xs:element name="EntityId3" type="xs:string"/>
-    <xs:element name="EntityId4" type="xs:string"/>
-    <xs:element name="EntityId5" type="xs:string"/>
-    <xs:element name="Terms">
-      <xs:complexType>
-        <xs:sequence>
-          <xs:element ref="pc:TermInfo" minOccurs="0" maxOccurs="unbounded"/>
-        </xs:sequence>
-      </xs:complexType>
-    </xs:element>
-    <xs:element name="TermInfo">
-      <xs:complexType>
-        <xs:sequence>
-          <xs:element ref="pc:TermName" minOccurs="0"/>
-          <xs:element ref="pc:TermId" minOccurs="0"/>
-        </xs:sequence>
-      </xs:complexType>
-    </xs:element>
-    <xs:element name="TermName" type="xs:string"/>
-    <xs:element name="TermId" type="xs:string"/>
-  </xs:schema>
-</ct:contentTypeSchema>
-</file>
-
-<file path=customXml/item2.xml><?xml version="1.0" encoding="utf-8"?>
-<?mso-contentType ?>
-<FormTemplates xmlns="http://schemas.microsoft.com/sharepoint/v3/contenttype/forms">
-  <Display>DocumentLibraryForm</Display>
-  <Edit>DocumentLibraryForm</Edit>
-  <New>DocumentLibraryForm</New>
-</FormTemplates>
-</file>
-
-<file path=customXml/item3.xml><?xml version="1.0" encoding="utf-8"?>
-<p:properties xmlns:p="http://schemas.microsoft.com/office/2006/metadata/properties" xmlns:xsi="http://www.w3.org/2001/XMLSchema-instance" xmlns:pc="http://schemas.microsoft.com/office/infopath/2007/PartnerControls">
-  <documentManagement/>
-</p:properties>
-</file>
-
-<file path=customXml/itemProps1.xml><?xml version="1.0" encoding="utf-8"?>
-<ds:datastoreItem xmlns:ds="http://schemas.openxmlformats.org/officeDocument/2006/customXml" ds:itemID="{90543ACA-0080-4F1B-9A43-6D163ABF9D83}"/>
-</file>
-
-<file path=customXml/itemProps2.xml><?xml version="1.0" encoding="utf-8"?>
-<ds:datastoreItem xmlns:ds="http://schemas.openxmlformats.org/officeDocument/2006/customXml" ds:itemID="{421A96B9-6778-4816-9FBB-CD583C2BFA91}"/>
-</file>
-
-<file path=customXml/itemProps3.xml><?xml version="1.0" encoding="utf-8"?>
-<ds:datastoreItem xmlns:ds="http://schemas.openxmlformats.org/officeDocument/2006/customXml" ds:itemID="{554756CF-1238-4708-9A63-6FAA5836CF73}"/>
 </file>
</xml_diff>